<commit_message>
Memoire et rapport : introduction sur une page, allegement, script oral
- Introduction (memoire et rapport) : recit du patient, mission, consentement
  par finalite (realise) et par type de dossier (en cours), plan ; tient sur
  une page. Mots-cles retires du Resume.
- Rapport : chapitres 2, 4, 5 et 7 alleges (redondances), legendes courtes,
  symboles du tableau comparatif remplaces par oui/partiel/non, figures,
  tableaux et captures redondants supprimes ou fusionnes (75 -> 67 pages).
- Generateur du rapport : reference fichier/lignes des extraits de code
  deplacee de la legende vers l'en-tete de l'encadre.
- Memoire : figure 9 (strategie de test) corrigee (planification a part,
  API des indicateurs Flask).
- Soutenance : script oral reecrit pour le deck de 20 slides ; notes de
  l'orateur alignees ; perspective « consentement par type de dossier ».

Co-Authored-By: Claude Opus 5.5 <noreply@anthropic.com>
</commit_message>
<xml_diff>
--- a/documents/slide_soutenance/Soutenance_M2_MBDS_RANOMENJANAHARY.pptx
+++ b/documents/slide_soutenance/Soutenance_M2_MBDS_RANOMENJANAHARY.pptx
@@ -1014,7 +1014,13 @@
           <a:lstStyle/>
           <a:p>
             <a:r>
-              <a:t>Bonjour. Je présente mon stage de Master MBDS réalisé chez Madagascar Medical Technology : la conception d'une plateforme Big Data qui centralise des données patients, reconnaît les doublons de façon explicable et contrôle chaque accès selon le consentement du patient. Toutes les données manipulées sont synthétiques.</a:t>
+              <a:t>Bonjour à toutes et à tous. Je suis Ranomenjanahary Manjaka Alpha, en master MBDS. Je vais vous présenter mon stage chez Madagascar Medical Technology : une plateforme qui rassemble les dossiers d'un même patient dispersés entre plusieurs services, et qui ne laisse lire ces dossiers que si le patient l'a accepté. Toutes les données que je vais montrer sont fictives.</a:t>
+            </a:r>
+          </a:p>
+          <a:p/>
+          <a:p>
+            <a:r>
+              <a:t>→ Quelques mots d'abord sur l'entreprise qui m'a accueilli.</a:t>
             </a:r>
           </a:p>
         </p:txBody>
@@ -1084,7 +1090,13 @@
           <a:lstStyle/>
           <a:p>
             <a:r>
-              <a:t>L'analyse fait ressortir cinq manques : pas d'identifiant transversal, le CIN manque pour un quart des patients ; pas de normalisation commune ; pas de rapprochement d'identités ; pas de gouvernance ; pas d'espace de rejeu. Le premier prototype comptait 24 872 marqueurs de doublon sans référentiel ni justification : on détectait, on n'expliquait pas.</a:t>
+              <a:t>Pas d'identifiant commun : le CIN manque pour environ un quart des patients. Pas de format commun. Pas de rapprochement explicable. Pas de gouvernance. Et pas d'espace pour rejouer un traitement. Le premier prototype comptait 24 872 marqueurs de doublon, mais sans jamais dire pourquoi : on détectait, on n'expliquait pas.</a:t>
+            </a:r>
+          </a:p>
+          <a:p/>
+          <a:p>
+            <a:r>
+              <a:t>→ Ma réponse a commencé petit.</a:t>
             </a:r>
           </a:p>
         </p:txBody>
@@ -1154,7 +1166,19 @@
           <a:lstStyle/>
           <a:p>
             <a:r>
-              <a:t>Je n'ai pas commencé par le Big Data. Niveau 1 : un MVP Pandas et PostgreSQL pour résoudre le problème métier. Niveau 2 : le même moteur porté en Spark, avec des résultats strictement identiques. Niveau 3 : le lac de données Medallion sur HDFS, Hive et Spark. Deux garde-fous transverses : on valide sur une vérité terrain avant de passer à l'échelle, et la gouvernance s'appuie sur la zone GOLD.</a:t>
+              <a:t>Je n'ai pas commencé par le Big Data. Niveau 1 : un prototype simple, en Pandas et PostgreSQL, pour vérifier que le problème métier se résout. Niveau 2 : le même moteur porté en Spark, avec des résultats strictement identiques. Niveau 3 : le lac de données sur HDFS, Hive et Spark.</a:t>
+            </a:r>
+          </a:p>
+          <a:p/>
+          <a:p>
+            <a:r>
+              <a:t>Deux garde-fous : je n'ai changé d'échelle qu'après avoir validé la qualité sur une vérité terrain, et je n'ai ouvert les accès qu'une fois la gouvernance en place. Chaque technologie arrive parce qu'un besoin l'exige.</a:t>
+            </a:r>
+          </a:p>
+          <a:p/>
+          <a:p>
+            <a:r>
+              <a:t>→ Voici le chemin d'une donnée dans l'architecture finale.</a:t>
             </a:r>
           </a:p>
         </p:txBody>
@@ -1224,7 +1248,13 @@
           <a:lstStyle/>
           <a:p>
             <a:r>
-              <a:t>Le chemin d'une donnée : les sources sont copiées telles quelles dans la zone RAW, sur HDFS. Le mapping FHIR produit la zone SILVER, où le moteur de déduplication rattache chaque ligne à son patient maître. La zone GOLD porte les agrégats et le consentement. PostgreSQL conserve l'état de référence : patients maîtres, consentements, audit. L'API de gouvernance est le seul point d'accès, et chaque appel est journalisé. Le tout tourne sur une VM de 8 Go, en outils libres.</a:t>
+              <a:t>Les sources sont copiées telles quelles dans la zone RAW, sur HDFS. Elles sont ensuite harmonisées au format FHIR dans la zone SILVER, où le moteur rattache chaque fiche à son patient maître. La zone GOLD porte les agrégats et le consentement. PostgreSQL garde l'état de référence : patients maîtres, consentements, journal d'audit. Et l'API de gouvernance est la seule porte d'entrée : chaque appel y est journalisé. Le tout tourne sur une machine virtuelle de 8 Go, avec des outils libres.</a:t>
+            </a:r>
+          </a:p>
+          <a:p/>
+          <a:p>
+            <a:r>
+              <a:t>→ Le cœur de cette architecture, c'est le moteur de déduplication.</a:t>
             </a:r>
           </a:p>
         </p:txBody>
@@ -1294,7 +1324,25 @@
           <a:lstStyle/>
           <a:p>
             <a:r>
-              <a:t>Le moteur compare seulement des candidats plausibles grâce au blocking. Première passe : rapprochement exact sur le nom normalisé, la date de naissance et le CIN. Sinon, un score pondéré : le nom compte pour moitié, la date pour 0,3, le CIN et la ville pour 0,1 chacun. Au-dessus de 0,80, on fusionne ; en dessous, on crée un nouveau patient maître. Chaque décision porte sa méthode, son score et son explication. Les poids sont dans un fichier de configuration.</a:t>
+              <a:t>Sa règle tient en une phrase : aucune fusion sans justification.</a:t>
+            </a:r>
+          </a:p>
+          <a:p/>
+          <a:p>
+            <a:r>
+              <a:t>Pour ne pas comparer tout le monde avec tout le monde, le moteur ne compare que des candidats plausibles : même début de nom, même date de naissance ou même CIN. Puis deux passes. D'abord une passe exacte : même nom normalisé, même date, même CIN. Sinon, un score pondéré : le nom compte pour moitié, la date pour 0,3, le CIN et la ville pour 0,1 chacun. Au-dessus de 0,80, on rattache ; en dessous, on crée un nouveau patient.</a:t>
+            </a:r>
+          </a:p>
+          <a:p/>
+          <a:p>
+            <a:r>
+              <a:t>Chaque décision porte sa méthode, son score et son explication. Un gestionnaire peut donc la relire, et la contester.</a:t>
+            </a:r>
+          </a:p>
+          <a:p/>
+          <a:p>
+            <a:r>
+              <a:t>→ Une fois l'identité établie, reste à savoir qui peut la lire.</a:t>
             </a:r>
           </a:p>
         </p:txBody>
@@ -1364,7 +1412,19 @@
           <a:lstStyle/>
           <a:p>
             <a:r>
-              <a:t>Trois contrôles, dans cet ordre. Qui : la clé d'API est résolue en utilisateur et en rôle ; clé inconnue, 401 ; rôle insuffisant, 403. Pourquoi : la finalité est obligatoire, dans une liste fermée ; finalité inconnue, 422 ; finalité non consentie, 403, même pour un utilisateur autorisé. Trace : chaque appel, accepté ou refusé, est journalisé avec la finalité et le motif du refus.</a:t>
+              <a:t>Trois contrôles, dans cet ordre. Qui demande ? La clé d'API donne l'utilisateur et son rôle ; une clé inconnue, c'est 401. Pourquoi ? La finalité est obligatoire ; si le patient ne l'a pas acceptée, c'est 403, même pour un utilisateur autorisé. Et la trace : chaque appel, accepté ou refusé, est journalisé avec son motif.</a:t>
+            </a:r>
+          </a:p>
+          <a:p/>
+          <a:p>
+            <a:r>
+              <a:t>Aujourd'hui, le patient choisit par finalité : consultation via l'API, recherche, statistiques. L'étape suivante, en cours de développement, c'est le choix par type de dossier : accepter qu'on lise ses consultations, mais refuser l'imagerie.</a:t>
+            </a:r>
+          </a:p>
+          <a:p/>
+          <a:p>
+            <a:r>
+              <a:t>→ Qu'est-ce que tout cela donne sur des données ?</a:t>
             </a:r>
           </a:p>
         </p:txBody>
@@ -1434,7 +1494,13 @@
           <a:lstStyle/>
           <a:p>
             <a:r>
-              <a:t>Le run de référence du 7 septembre 2026, sur les trois sources synthétiques : 214 lignes en zone SILVER, 145 patients maîtres, 69 doublons rattachés, soit 32,24 % de doublons. La cohérence se vérifie par un simple comptage : 214 moins 69 égale 145. Le pipeline a réussi toutes ses étapes, et la suite de tests passe à 102 sur 102.</a:t>
+              <a:t>Sur le jeu de démonstration du 7 septembre : 214 fiches, 145 patients distincts, 69 doublons rattachés, soit 32 % de doublons. Et la cohérence se vérifie par une simple soustraction : 214 moins 69, 145. Le pipeline a réussi toutes ses étapes, et les 102 tests passent.</a:t>
+            </a:r>
+          </a:p>
+          <a:p/>
+          <a:p>
+            <a:r>
+              <a:t>→ Mais ces 145 patients sont-ils les bons ?</a:t>
             </a:r>
           </a:p>
         </p:txBody>
@@ -1504,7 +1570,25 @@
           <a:lstStyle/>
           <a:p>
             <a:r>
-              <a:t>Pour mesurer la qualité, il faut connaître la vérité : un générateur produit 500 patients et leurs variantes, avec 10, 30 ou 50 % de variations. La précision est de 1,000 sur les trois niveaux : aucune fusion à tort, c'est la propriété essentielle en santé. Le rappel baisse sur le jeu difficile, 0,422 : c'est le prix d'un seuil prudent, assumé. Le CIN l'a fait passer de 0,287 à 0,422. Pandas et Spark donnent exactement les mêmes résultats.</a:t>
+              <a:t>Pour le savoir, il faut connaître la vérité. J'ai donc généré 500 patients fictifs, puis trois jeux où 10, 30 ou 50 % des fiches sont abîmées : fautes de frappe, inversions, formats.</a:t>
+            </a:r>
+          </a:p>
+          <a:p/>
+          <a:p>
+            <a:r>
+              <a:t>Résultat principal : zéro fusion à tort, sur les trois niveaux. En santé, c'est la propriété qui compte : confondre deux patients est plus grave que de les laisser séparés. Je dois être honnête sur sa portée : c'est un plancher, car mon générateur ne crée pas de sosies, deux personnes différentes qui se ressemblent.</a:t>
+            </a:r>
+          </a:p>
+          <a:p/>
+          <a:p>
+            <a:r>
+              <a:t>Le prix de cette prudence, c'est le rappel : 0,422 sur le jeu difficile, après être parti de 0,287. Et Pandas et Spark donnent exactement les mêmes résultats.</a:t>
+            </a:r>
+          </a:p>
+          <a:p/>
+          <a:p>
+            <a:r>
+              <a:t>→ Je vous montre maintenant la chaîne en fonctionnement.</a:t>
             </a:r>
           </a:p>
         </p:txBody>
@@ -1574,7 +1658,43 @@
           <a:lstStyle/>
           <a:p>
             <a:r>
-              <a:t>Vidéo enregistrée de 3 minutes 30, pour ne dépendre ni du réseau ni de la VM le jour J. On y voit les tests, l'évaluation sur le jeu difficile, un run du pipeline jusqu'à la zone GOLD, puis le tableau de bord. Si la vidéo ne se lance pas, je présente les compteurs figés.</a:t>
+              <a:t>La vidéo suit l'ordre de construction du projet : les tests, l'évaluation, le pipeline, puis le tableau de bord.</a:t>
+            </a:r>
+          </a:p>
+          <a:p/>
+          <a:p>
+            <a:r>
+              <a:t>102 tests, aucun échec : moteur, gouvernance, planification.</a:t>
+            </a:r>
+          </a:p>
+          <a:p/>
+          <a:p>
+            <a:r>
+              <a:t>Précision 1,000, rappel 0,422, mêmes décisions en Pandas et en Spark.</a:t>
+            </a:r>
+          </a:p>
+          <a:p/>
+          <a:p>
+            <a:r>
+              <a:t>Les étapes s'enchaînent jusqu'à la zone GOLD.</a:t>
+            </a:r>
+          </a:p>
+          <a:p/>
+          <a:p>
+            <a:r>
+              <a:t>Les zones, le dernier run et la planification.</a:t>
+            </a:r>
+          </a:p>
+          <a:p/>
+          <a:p>
+            <a:r>
+              <a:t>Les mêmes preuves en chiffres : 214, 145, 69.</a:t>
+            </a:r>
+          </a:p>
+          <a:p/>
+          <a:p>
+            <a:r>
+              <a:t>→ Ce que je n'ai pas résolu.</a:t>
             </a:r>
           </a:p>
         </p:txBody>
@@ -1644,7 +1764,19 @@
           <a:lstStyle/>
           <a:p>
             <a:r>
-              <a:t>Je préfère nommer les limites. Le rappel sur le jeu difficile est de 0,422. La table GOLD des événements est vide, car les consultations ne sont pas encore rattachées au patient. La base centrale de consentements n'a pas été peuplée : la mécanique est testée, la donnée manque. Et la plateforme n'est pas déployée. La suite : compléter le mapping FHIR, peupler les consentements, calibrer le seuil, puis intégration continue et passage à l'échelle. Avant toute production : vérifier le droit malgache des données de santé.</a:t>
+              <a:t>Je préfère nommer les limites. Le rappel sur le jeu difficile reste à 0,422. La table des événements de soin est vide : les consultations ne sont pas encore rattachées au patient. La base centrale des consentements n'a pas été peuplée. Et la plateforme n'est pas déployée : c'est un prototype reproductible.</a:t>
+            </a:r>
+          </a:p>
+          <a:p/>
+          <a:p>
+            <a:r>
+              <a:t>La suite : terminer le consentement par type de dossier, compléter le rattachement des consultations, calibrer le seuil. Et avant toute mise en production, vérifier le droit malgache des données de santé.</a:t>
+            </a:r>
+          </a:p>
+          <a:p/>
+          <a:p>
+            <a:r>
+              <a:t>→ Pour conclure.</a:t>
             </a:r>
           </a:p>
         </p:txBody>
@@ -1714,7 +1846,7 @@
           <a:lstStyle/>
           <a:p>
             <a:r>
-              <a:t>Pour conclure : la plateforme centralise dans un lac Medallion, normalise avec un modèle canonique et FHIR, déduplique sans jamais fusionner à tort, et gouverne chaque accès par le consentement, avec un audit. La démarche progressive a tenu : changer d'échelle n'a pas changé la logique. Et chaque résultat se vérifie dans le dépôt.</a:t>
+              <a:t>La plateforme centralise, normalise, déduplique sans jamais fusionner à tort, et contrôle chaque accès par le consentement. Changer d'échelle n'a pas changé la logique. Et derrière chaque chiffre, il y a ce patient du début : reconnu comme une seule personne, et maître de l'usage de ses données.</a:t>
             </a:r>
           </a:p>
         </p:txBody>
@@ -1784,7 +1916,19 @@
           <a:lstStyle/>
           <a:p>
             <a:r>
-              <a:t>MMT a été créée en 2009. Elle distribue et maintient du matériel biomédical, fournit des consommables et gère des stocks. Elle est Business Partner de Siemens Healthineers. Depuis 2024, son département R&amp;D gère les systèmes d'information médicale : c'est là que j'ai fait mon stage, du 6 juillet à fin octobre 2026.</a:t>
+              <a:t>MMT a été créée en 2009. Son métier historique, c'est le matériel biomédical : distribution, maintenance, consommables. Elle est Business Partner de Siemens Healthineers. Depuis 2024, elle a un département Recherche et Développement, qui gère des systèmes d'information médicale : c'est là que j'ai passé quatre mois, de juillet à fin octobre.</a:t>
+            </a:r>
+          </a:p>
+          <a:p/>
+          <a:p>
+            <a:r>
+              <a:t>J'ai choisi ce sujet parce qu'il réunit les trois volets du master : les bases de données, l'intégration de systèmes hétérogènes et le Big Data, que je voulais pratiquer et non plus seulement étudier.</a:t>
+            </a:r>
+          </a:p>
+          <a:p/>
+          <a:p>
+            <a:r>
+              <a:t>→ Voici le problème que j'ai trouvé en arrivant.</a:t>
             </a:r>
           </a:p>
         </p:txBody>
@@ -1854,7 +1998,7 @@
           <a:lstStyle/>
           <a:p>
             <a:r>
-              <a:t>Merci pour votre attention. Je suis prêt à répondre à vos questions.</a:t>
+              <a:t>Merci pour votre attention. Je suis à votre disposition pour vos questions.</a:t>
             </a:r>
           </a:p>
         </p:txBody>
@@ -1924,7 +2068,19 @@
           <a:lstStyle/>
           <a:p>
             <a:r>
-              <a:t>Voici le point de départ. Le même patient apparaît dans trois systèmes : Jean Rakoto en pharmacie, Rakoto Jean en consultation, J. RAKOTO en imagerie, avec des dates et des CIN écrits différemment. Aucun système ne sait qu'il s'agit de la même personne. Et une seconde question suit immédiatement : qui a le droit de lire son dossier, et pour quoi faire ?</a:t>
+              <a:t>Imaginez un patient. Il passe à la pharmacie, puis en consultation, puis à l'imagerie. À chaque étape, on l'enregistre de nouveau. En pharmacie, il s'appelle « Jean Rakoto ». En consultation, « Rakoto Jean ». À l'imagerie, « J. RAKOTO ». Le CIN et la date de naissance sont écrits autrement à chaque fois.</a:t>
+            </a:r>
+          </a:p>
+          <a:p/>
+          <a:p>
+            <a:r>
+              <a:t>Aucun de ces services ne sait que c'est la même personne. Et personne ne lui a demandé ce qu'il accepte que l'on fasse de ses données. Voilà les deux questions de mon stage : comment savoir que c'est lui ? Et qui a le droit de lire son dossier, pour quoi faire ?</a:t>
+            </a:r>
+          </a:p>
+          <a:p/>
+          <a:p>
+            <a:r>
+              <a:t>→ Derrière ce cas, il y a trois problèmes.</a:t>
             </a:r>
           </a:p>
         </p:txBody>
@@ -1994,7 +2150,19 @@
           <a:lstStyle/>
           <a:p>
             <a:r>
-              <a:t>Trois problèmes concrets : la dispersion, puisque les données d'un patient sont réparties entre plusieurs bases ; l'hétérogénéité, puisque identifiants, libellés et formats diffèrent ; et l'absence de gouvernance : rien ne dit qui accède à quoi, ni pourquoi. D'où la problématique.</a:t>
+              <a:t>Le premier, c'est la dispersion : le dossier d'un patient est éclaté entre plusieurs bases. Le deuxième, l'hétérogénéité : même le genre s'écrit H/F, male/female ou Homme/femme. Et ces sources ne sont pas figées : un service peut être séparé en plusieurs bases demain. Le troisième, l'absence de gouvernance : rien ne dit qui accède à quoi, ni pourquoi.</a:t>
+            </a:r>
+          </a:p>
+          <a:p/>
+          <a:p>
+            <a:r>
+              <a:t>Ma problématique est donc la suivante : comment centraliser et dédupliquer ces données, tout en gardant la trace des identités et en contrôlant chaque accès par le consentement du patient ?</a:t>
+            </a:r>
+          </a:p>
+          <a:p/>
+          <a:p>
+            <a:r>
+              <a:t>→ Le cahier des charges traduit cela en six objectifs.</a:t>
             </a:r>
           </a:p>
         </p:txBody>
@@ -2064,7 +2232,7 @@
           <a:lstStyle/>
           <a:p>
             <a:r>
-              <a:t>Le cahier des charges fixe six objectifs : centraliser, nettoyer, dédupliquer de façon explicable, gouverner les accès, visualiser et évaluer. Deux contraintes encadrent tout le travail : les données restent sur les machines de l'établissement, et seules des données synthétiques sont utilisées.</a:t>
+              <a:t>Six objectifs : centraliser, nettoyer, dédupliquer de façon explicable, gouverner les accès, visualiser et évaluer. Et deux contraintes non négociables : les données ne quittent pas l'établissement, et je n'ai travaillé que sur des données synthétiques.</a:t>
             </a:r>
           </a:p>
         </p:txBody>
@@ -2134,7 +2302,7 @@
           <a:lstStyle/>
           <a:p>
             <a:r>
-              <a:t>Je présente d'abord l'état de l'art et l'existant, puis la solution et ses fonctionnalités, les résultats mesurés, une démonstration, et enfin les limites et perspectives.</a:t>
+              <a:t>Je commence par l'état de l'art et l'existant, puis la solution et ses résultats, une démonstration, et je termine par les limites.</a:t>
             </a:r>
           </a:p>
         </p:txBody>
@@ -2204,7 +2372,13 @@
           <a:lstStyle/>
           <a:p>
             <a:r>
-              <a:t>Quatre notions reviennent partout. L'ELT : on charge le brut d'abord, on transforme ensuite. Le modèle Medallion : trois zones de qualité croissante, rejouables. Le Master Patient Index : l'annuaire qui reconnaît le même patient et lui donne un identifiant unique. Et le consentement par finalité : le patient autorise un usage précis, jamais un accès global ; sans avis, c'est un refus.</a:t>
+              <a:t>Quatre notions structurent tout le projet. L'ELT : on charge la donnée brute d'abord, on la transforme ensuite. Le modèle Medallion : trois zones de qualité croissante, RAW, SILVER et GOLD, qu'on peut rejouer. Le Master Patient Index : l'annuaire qui reconnaît un même patient et lui donne un identifiant unique. Et le consentement par finalité : le patient autorise un usage précis, jamais un accès global. Sans avis de sa part, c'est un refus.</a:t>
+            </a:r>
+          </a:p>
+          <a:p/>
+          <a:p>
+            <a:r>
+              <a:t>→ Existe-t-il déjà un produit qui fasse tout cela ?</a:t>
             </a:r>
           </a:p>
         </p:txBody>
@@ -2274,7 +2448,19 @@
           <a:lstStyle/>
           <a:p>
             <a:r>
-              <a:t>J'ai comparé six solutions sur six critères, sur la base de leur documentation — aucune n'a été installée. Les plus complètes sur l'identité, EMPI et Talend, sont lourdes, sous licence, et Azure est un service cloud, incompatible avec l'hébergement interne. D'où le choix d'une chaîne sur mesure, adossée aux standards : Fellegi-Sunter, FHIR, Medallion.</a:t>
+              <a:t>J'ai comparé six solutions sur six critères, à partir de leur documentation : je ne les ai pas installées. Les plus complètes sur l'identité, comme EMPI ou Talend, sont lourdes et sous licence. Azure est un service cloud, donc exclu par l'hébergement interne. Splink est excellent sur l'algorithme, mais ses poids sont difficiles à expliquer à un gestionnaire de données.</a:t>
+            </a:r>
+          </a:p>
+          <a:p/>
+          <a:p>
+            <a:r>
+              <a:t>Aucune ne coche les six critères. J'ai donc construit une chaîne sur mesure, mais adossée aux standards : Fellegi-Sunter pour la décision, FHIR pour le format, Medallion pour le lac.</a:t>
+            </a:r>
+          </a:p>
+          <a:p/>
+          <a:p>
+            <a:r>
+              <a:t>→ Côté établissement, qu'est-ce qui existait ?</a:t>
             </a:r>
           </a:p>
         </p:txBody>
@@ -2344,7 +2530,13 @@
           <a:lstStyle/>
           <a:p>
             <a:r>
-              <a:t>Trois systèmes ont été capturés. MAVIS, un ERP Odoo avec module hospitalier : 1 260 tables sur le nœud distant, 11 retenues. MMT_DB, sous GNU Health : 60 271 lignes. CLINIQUE, en SQLite : 54 582 lignes et aucune violation de clé. Chaque base est cohérente avec elle-même ; ce qui manque, c'est le pont entre elles.</a:t>
+              <a:t>Trois systèmes : MAVIS, sous Odoo, avec 1 260 tables sur le serveur distant ; MMT_DB, sous GNU Health ; et une base clinique en SQLite. Chacune est cohérente avec elle-même : la clinique n'a aucune violation de clé. Le problème n'est donc pas la qualité de chaque base. C'est l'absence de pont entre elles.</a:t>
+            </a:r>
+          </a:p>
+          <a:p/>
+          <a:p>
+            <a:r>
+              <a:t>→ Ce pont manquant se décompose en cinq manques.</a:t>
             </a:r>
           </a:p>
         </p:txBody>
@@ -15572,7 +15764,7 @@
                 </a:solidFill>
                 <a:latin typeface="Calibri"/>
               </a:rPr>
-              <a:t> : mapping FHIR, consentements peuplés, calibrage du seuil</a:t>
+              <a:t> : consentement par type de dossier, mapping FHIR, consentements peuplés, calibrage du seuil</a:t>
             </a:r>
           </a:p>
           <a:p>

</xml_diff>

<commit_message>
Soutenance : script oral et deck alignes sur les runs reels du 29-30/09
Co-Authored-By: Claude Opus 5.5 <noreply@anthropic.com>
</commit_message>
<xml_diff>
--- a/documents/slide_soutenance/Soutenance_M2_MBDS_RANOMENJANAHARY.pptx
+++ b/documents/slide_soutenance/Soutenance_M2_MBDS_RANOMENJANAHARY.pptx
@@ -1494,13 +1494,13 @@
           <a:lstStyle/>
           <a:p>
             <a:r>
-              <a:t>Sur le jeu de démonstration du 7 septembre : 214 fiches, 145 patients distincts, 69 doublons rattachés, soit 32 % de doublons. Et la cohérence se vérifie par une simple soustraction : 214 moins 69, 145. Le pipeline a réussi toutes ses étapes, et les 102 tests passent.</a:t>
+              <a:t>Sur le jeu difficile, rejoué dans la VM le 29 septembre : 1 057 fiches, 803 patients distincts, 254 doublons rattachés, soit 24 % de doublons. La cohérence se vérifie par une soustraction : 1 057 moins 254, 803. Les cinq étapes réussissent, et les 123 tests passent.</a:t>
             </a:r>
           </a:p>
           <a:p/>
           <a:p>
             <a:r>
-              <a:t>→ Mais ces 145 patients sont-ils les bons ?</a:t>
+              <a:t>→ Mais ces 803 patients sont-ils les bons ?</a:t>
             </a:r>
           </a:p>
         </p:txBody>
@@ -1576,13 +1576,13 @@
           <a:p/>
           <a:p>
             <a:r>
-              <a:t>Résultat principal : zéro fusion à tort, sur les trois niveaux. En santé, c'est la propriété qui compte : confondre deux patients est plus grave que de les laisser séparés. Je dois être honnête sur sa portée : c'est un plancher, car mon générateur ne crée pas de sosies, deux personnes différentes qui se ressemblent.</a:t>
+              <a:t>Résultat principal : zéro fusion à tort, sur les trois niveaux. En santé, c'est la propriété qui compte : confondre deux patients est plus grave que de les laisser séparés. Sa portée a une limite : mon générateur ne crée pas de sosies, deux personnes différentes qui se ressemblent. Ce résultat vaut donc pour les erreurs que j'ai simulées ; face à de vrais homonymes, c'est une estimation optimiste.</a:t>
             </a:r>
           </a:p>
           <a:p/>
           <a:p>
             <a:r>
-              <a:t>Le prix de cette prudence, c'est le rappel : 0,422 sur le jeu difficile, après être parti de 0,287. Et Pandas et Spark donnent exactement les mêmes résultats.</a:t>
+              <a:t>Le prix de cette prudence, c'est le rappel : 0,422 sur le jeu difficile, après être parti de 0,287. Pandas et Spark donnent exactement les mêmes résultats, et le pipeline complet, mesuré sur la même vérité terrain, aussi : précision 1,000, rappel 0,424.</a:t>
             </a:r>
           </a:p>
           <a:p/>
@@ -1664,7 +1664,7 @@
           <a:p/>
           <a:p>
             <a:r>
-              <a:t>102 tests, aucun échec : moteur, gouvernance, planification.</a:t>
+              <a:t>123 tests, aucun échec : moteur, gouvernance, pipeline.</a:t>
             </a:r>
           </a:p>
           <a:p/>
@@ -1688,7 +1688,7 @@
           <a:p/>
           <a:p>
             <a:r>
-              <a:t>Les mêmes preuves en chiffres : 214, 145, 69.</a:t>
+              <a:t>Les mêmes preuves en chiffres : 1 057, 803, 254.</a:t>
             </a:r>
           </a:p>
           <a:p/>
@@ -1764,13 +1764,13 @@
           <a:lstStyle/>
           <a:p>
             <a:r>
-              <a:t>Je préfère nommer les limites. Le rappel sur le jeu difficile reste à 0,422. La table des événements de soin est vide : les consultations ne sont pas encore rattachées au patient. La base centrale des consentements n'a pas été peuplée. Et la plateforme n'est pas déployée : c'est un prototype reproductible.</a:t>
+              <a:t>Je préfère nommer les limites. Le rappel sur le jeu difficile reste à 0,42. La planification automatique n'a pas encore été activée. La base centrale est une base de test, avec des consentements de démonstration. Et la plateforme n'est pas déployée : c'est un prototype reproductible.</a:t>
             </a:r>
           </a:p>
           <a:p/>
           <a:p>
             <a:r>
-              <a:t>La suite : terminer le consentement par type de dossier, compléter le rattachement des consultations, calibrer le seuil. Et avant toute mise en production, vérifier le droit malgache des données de santé.</a:t>
+              <a:t>La suite : terminer le consentement par type de dossier, calibrer le seuil, activer la planification. Et avant toute mise en production, vérifier le droit malgache des données de santé.</a:t>
             </a:r>
           </a:p>
           <a:p/>
@@ -12844,7 +12844,7 @@
                 </a:solidFill>
                 <a:latin typeface="Calibri"/>
               </a:rPr>
-              <a:t>Sur le jeu de démonstration : 214 fiches ramenées à 145 patients</a:t>
+              <a:t>Sur le jeu difficile : 1 057 fiches ramenées à 803 patients</a:t>
             </a:r>
           </a:p>
         </p:txBody>
@@ -12926,7 +12926,7 @@
                 </a:solidFill>
                 <a:latin typeface="Calibri"/>
               </a:rPr>
-              <a:t>214</a:t>
+              <a:t>1 057</a:t>
             </a:r>
           </a:p>
         </p:txBody>
@@ -12962,7 +12962,7 @@
                 <a:latin typeface="Calibri"/>
               </a:rPr>
               <a:t>fiches dans la zone SILVER
-(76 + 76 + 62)</a:t>
+(404 + 353 + 300)</a:t>
             </a:r>
           </a:p>
         </p:txBody>
@@ -13089,7 +13089,7 @@
                 </a:solidFill>
                 <a:latin typeface="Calibri"/>
               </a:rPr>
-              <a:t>145</a:t>
+              <a:t>803</a:t>
             </a:r>
           </a:p>
         </p:txBody>
@@ -13206,7 +13206,7 @@
                 </a:solidFill>
                 <a:latin typeface="Calibri"/>
               </a:rPr>
-              <a:t>69</a:t>
+              <a:t>254</a:t>
             </a:r>
           </a:p>
         </p:txBody>
@@ -13323,7 +13323,7 @@
                 </a:solidFill>
                 <a:latin typeface="Calibri"/>
               </a:rPr>
-              <a:t>32,24 %</a:t>
+              <a:t>24,03 %</a:t>
             </a:r>
           </a:p>
         </p:txBody>
@@ -13393,7 +13393,7 @@
                 </a:solidFill>
                 <a:latin typeface="Calibri"/>
               </a:rPr>
-              <a:t>214 − 69 = 145</a:t>
+              <a:t>1 057 − 254 = 803</a:t>
             </a:r>
           </a:p>
         </p:txBody>
@@ -13463,7 +13463,7 @@
                 </a:solidFill>
                 <a:latin typeface="Calibri"/>
               </a:rPr>
-              <a:t>4 / 4</a:t>
+              <a:t>5 / 5</a:t>
             </a:r>
           </a:p>
         </p:txBody>
@@ -13498,7 +13498,7 @@
                 </a:solidFill>
                 <a:latin typeface="Calibri"/>
               </a:rPr>
-              <a:t>étapes du pipeline réussies (run du 07/09/2026)</a:t>
+              <a:t>étapes du pipeline réussies (run du 29/09/2026)</a:t>
             </a:r>
           </a:p>
         </p:txBody>
@@ -13533,7 +13533,7 @@
                 </a:solidFill>
                 <a:latin typeface="Calibri"/>
               </a:rPr>
-              <a:t>102 / 102</a:t>
+              <a:t>123 / 123</a:t>
             </a:r>
           </a:p>
         </p:txBody>
@@ -13568,7 +13568,7 @@
                 </a:solidFill>
                 <a:latin typeface="Calibri"/>
               </a:rPr>
-              <a:t>tests automatisés réussis (moteur, gouvernance, planification)</a:t>
+              <a:t>tests automatisés réussis (moteur, gouvernance, pipeline)</a:t>
             </a:r>
           </a:p>
         </p:txBody>
@@ -13603,7 +13603,7 @@
                 </a:solidFill>
                 <a:latin typeface="Calibri"/>
               </a:rPr>
-              <a:t>Sources CSV synthétiques (graine 42) — aucune donnée réelle.</a:t>
+              <a:t>Jeu d'évaluation difficile, données synthétiques — aucune donnée réelle.</a:t>
             </a:r>
           </a:p>
         </p:txBody>
@@ -14744,7 +14744,7 @@
                 </a:solidFill>
                 <a:latin typeface="Calibri"/>
               </a:rPr>
-              <a:t>Tests automatisés : 102 / 102</a:t>
+              <a:t>Tests automatisés : 123 / 123</a:t>
             </a:r>
           </a:p>
         </p:txBody>
@@ -15104,7 +15104,7 @@
                 </a:solidFill>
                 <a:latin typeface="Calibri"/>
               </a:rPr>
-              <a:t>Repli : compteurs figés 214 · 145 · 69</a:t>
+              <a:t>Repli : compteurs figés 1 057 · 803 · 254</a:t>
             </a:r>
           </a:p>
         </p:txBody>
@@ -15536,7 +15536,7 @@
                 </a:solidFill>
                 <a:latin typeface="Calibri"/>
               </a:rPr>
-              <a:t>Table GOLD des </a:t>
+              <a:t>Planification </a:t>
             </a:r>
             <a:r>
               <a:rPr sz="1600" b="1" i="0">
@@ -15545,7 +15545,7 @@
                 </a:solidFill>
                 <a:latin typeface="Calibri"/>
               </a:rPr>
-              <a:t>événements vide</a:t>
+              <a:t>cron non activée</a:t>
             </a:r>
             <a:r>
               <a:rPr sz="1600" b="0" i="0">
@@ -15554,7 +15554,7 @@
                 </a:solidFill>
                 <a:latin typeface="Calibri"/>
               </a:rPr>
-              <a:t> : rattachement FHIR à compléter</a:t>
+              <a:t> : logique testée, pas encore observée</a:t>
             </a:r>
           </a:p>
           <a:p>
@@ -15574,7 +15574,7 @@
                 </a:solidFill>
                 <a:latin typeface="Calibri"/>
               </a:rPr>
-              <a:t>Base de consentements </a:t>
+              <a:t>Base centrale </a:t>
             </a:r>
             <a:r>
               <a:rPr sz="1600" b="1" i="0">
@@ -15583,7 +15583,7 @@
                 </a:solidFill>
                 <a:latin typeface="Calibri"/>
               </a:rPr>
-              <a:t>non peuplée</a:t>
+              <a:t>de test</a:t>
             </a:r>
             <a:r>
               <a:rPr sz="1600" b="0" i="0">
@@ -15592,7 +15592,7 @@
                 </a:solidFill>
                 <a:latin typeface="Calibri"/>
               </a:rPr>
-              <a:t> : mécanique testée, donnée absente</a:t>
+              <a:t> : consentements de démonstration</a:t>
             </a:r>
           </a:p>
           <a:p>
@@ -15764,7 +15764,7 @@
                 </a:solidFill>
                 <a:latin typeface="Calibri"/>
               </a:rPr>
-              <a:t> : consentement par type de dossier, mapping FHIR, consentements peuplés, calibrage du seuil</a:t>
+              <a:t> : consentement par type de dossier, calibrage du seuil, activation du cron</a:t>
             </a:r>
           </a:p>
           <a:p>
@@ -16369,7 +16369,7 @@
                 </a:solidFill>
                 <a:latin typeface="Calibri"/>
               </a:rPr>
-              <a:t>214 fiches intégrées</a:t>
+              <a:t>1 057 fiches intégrées</a:t>
             </a:r>
           </a:p>
         </p:txBody>

</xml_diff>

<commit_message>
Memoire, rapport, soutenance : regle d'identite stricte (v2) en evolution mesuree
La v1 (score pondere, seuil 0,80) est presentee comme premiere version,
resultats conserves en comparaison ; la v2 (CIN, genre, date et ville
identiques, executee dans Spark, identifiant derive de la cle) est le
moteur actuel. Tableau 44 v1/v2 (100 000 patients : 13 paires a tort en
v1, 0 en v2), limites et perspectives revues, 12e incident, figures 1, 5,
6 et 9 re-rendues, glossaire (HMAC, UDF). Rapport, script oral (debit
recompte), deck (S13, S15-S18, graphique et notes) et documentation alignes.

Co-Authored-By: Claude Opus 5.5 <noreply@anthropic.com>
</commit_message>
<xml_diff>
--- a/documents/slide_soutenance/Soutenance_M2_MBDS_RANOMENJANAHARY.pptx
+++ b/documents/slide_soutenance/Soutenance_M2_MBDS_RANOMENJANAHARY.pptx
@@ -325,13 +325,13 @@
                 <c:formatCode>General</c:formatCode>
                 <c:ptCount val="3"/>
                 <c:pt idx="0">
-                  <c:v>1</c:v>
+                  <c:v>1.0</c:v>
                 </c:pt>
                 <c:pt idx="1">
-                  <c:v>1</c:v>
+                  <c:v>1.0</c:v>
                 </c:pt>
                 <c:pt idx="2">
-                  <c:v>1</c:v>
+                  <c:v>1.0</c:v>
                 </c:pt>
               </c:numCache>
             </c:numRef>
@@ -419,7 +419,7 @@
                           <a:srgbClr val="1D2433"/>
                         </a:solidFill>
                       </a:rPr>
-                      <a:t>0,884</a:t>
+                      <a:t>0,824</a:t>
                     </a:r>
                   </a:p>
                 </c:rich>
@@ -453,7 +453,7 @@
                           <a:srgbClr val="1D2433"/>
                         </a:solidFill>
                       </a:rPr>
-                      <a:t>0,422</a:t>
+                      <a:t>0,179</a:t>
                     </a:r>
                   </a:p>
                 </c:rich>
@@ -517,13 +517,13 @@
                 <c:formatCode>General</c:formatCode>
                 <c:ptCount val="3"/>
                 <c:pt idx="0">
-                  <c:v>1</c:v>
+                  <c:v>1.0</c:v>
                 </c:pt>
                 <c:pt idx="1">
-                  <c:v>0.88400000000000001</c:v>
+                  <c:v>0.824</c:v>
                 </c:pt>
                 <c:pt idx="2">
-                  <c:v>0.42199999999999999</c:v>
+                  <c:v>0.179</c:v>
                 </c:pt>
               </c:numCache>
             </c:numRef>
@@ -611,7 +611,7 @@
                           <a:srgbClr val="1D2433"/>
                         </a:solidFill>
                       </a:rPr>
-                      <a:t>0,939</a:t>
+                      <a:t>0,903</a:t>
                     </a:r>
                   </a:p>
                 </c:rich>
@@ -645,7 +645,7 @@
                           <a:srgbClr val="1D2433"/>
                         </a:solidFill>
                       </a:rPr>
-                      <a:t>0,594</a:t>
+                      <a:t>0,303</a:t>
                     </a:r>
                   </a:p>
                 </c:rich>
@@ -709,13 +709,13 @@
                 <c:formatCode>General</c:formatCode>
                 <c:ptCount val="3"/>
                 <c:pt idx="0">
-                  <c:v>1</c:v>
+                  <c:v>1.0</c:v>
                 </c:pt>
                 <c:pt idx="1">
-                  <c:v>0.93899999999999995</c:v>
+                  <c:v>0.903</c:v>
                 </c:pt>
                 <c:pt idx="2">
-                  <c:v>0.59399999999999997</c:v>
+                  <c:v>0.303</c:v>
                 </c:pt>
               </c:numCache>
             </c:numRef>
@@ -1324,19 +1324,19 @@
           <a:lstStyle/>
           <a:p>
             <a:r>
-              <a:t>Sa règle tient en une phrase : aucune fusion sans justification.</a:t>
+              <a:t>Sa règle tient en une phrase : aucune fusion sans identité identique.</a:t>
             </a:r>
           </a:p>
           <a:p/>
           <a:p>
             <a:r>
-              <a:t>Pour ne pas comparer tout le monde avec tout le monde, le moteur ne compare que des candidats plausibles : même début de nom, même date de naissance ou même CIN. Puis deux passes. D'abord une passe exacte : même nom normalisé, même date, même CIN. Sinon, un score pondéré : le nom compte pour moitié, la date pour 0,3, le CIN et la ville pour 0,1 chacun. Au-dessus de 0,80, on rattache ; en dessous, on crée un nouveau patient.</a:t>
+              <a:t>Deux fiches sont réunies si, et seulement si, elles ont le même CIN, le même genre, la même date et la même ville de naissance. Sans CIN, le nom doit être identique en plus. Il n'y a ni score ni seuil : qu'un champ manque, et la fiche reste seule.</a:t>
             </a:r>
           </a:p>
           <a:p/>
           <a:p>
             <a:r>
-              <a:t>Chaque décision porte sa méthode, son score et son explication. Un gestionnaire peut donc la relire, et la contester.</a:t>
+              <a:t>J'ai d'abord utilisé un score pondéré. Sur 100 000 patients, il a réuni deux homonymes parfaits, aux CIN différents. J'ai donc choisi la règle stricte. Chaque décision porte sa méthode et son explication, et l'identifiant du patient, dérivé de sa clé, ne change pas d'un run à l'autre.</a:t>
             </a:r>
           </a:p>
           <a:p/>
@@ -1494,13 +1494,13 @@
           <a:lstStyle/>
           <a:p>
             <a:r>
-              <a:t>Sur le jeu difficile, rejoué dans la VM le 29 septembre : 1 057 fiches, 803 patients distincts, 254 doublons rattachés, soit 24 % de doublons. La cohérence se vérifie par une soustraction : 1 057 moins 254, 803. Les cinq étapes réussissent, et les 123 tests passent.</a:t>
+              <a:t>Sur le jeu difficile, rejoué dans la VM : 1 057 fiches, 942 patients distincts, 115 doublons rattachés. La cohérence se vérifie par une soustraction : 1 057 moins 115, 942. Sur 100 000 patients, le run complet prend moins de trois minutes. Et les 131 tests passent.</a:t>
             </a:r>
           </a:p>
           <a:p/>
           <a:p>
             <a:r>
-              <a:t>→ Mais ces 803 patients sont-ils les bons ?</a:t>
+              <a:t>→ Mais ces 942 patients sont-ils les bons ?</a:t>
             </a:r>
           </a:p>
         </p:txBody>
@@ -1570,19 +1570,19 @@
           <a:lstStyle/>
           <a:p>
             <a:r>
-              <a:t>Pour le savoir, il faut connaître la vérité. J'ai donc généré 500 patients fictifs, puis trois jeux où 10, 30 ou 50 % des fiches sont abîmées : fautes de frappe, inversions, formats.</a:t>
+              <a:t>Pour le savoir, il faut connaître la vérité. J'ai donc généré des patients fictifs, puis des jeux où 10, 30 ou 50 % des fiches sont abîmées : fautes de frappe, inversions, champs effacés.</a:t>
             </a:r>
           </a:p>
           <a:p/>
           <a:p>
             <a:r>
-              <a:t>Résultat principal : zéro fusion à tort, sur les trois niveaux. En santé, c'est la propriété qui compte : confondre deux patients est plus grave que de les laisser séparés. Sa portée a une limite : mon générateur ne crée pas de sosies, deux personnes différentes qui se ressemblent. Ce résultat vaut donc pour les erreurs que j'ai simulées ; face à de vrais homonymes, c'est une estimation optimiste.</a:t>
+              <a:t>Résultat principal : zéro fusion à tort, sur tous les jeux, y compris à 100 000 patients. En santé, c'est la propriété qui compte : confondre deux patients est plus grave que de les laisser séparés. Sa portée a une limite : mes données ne contiennent pas de CIN partagé par deux personnes. C'est donc une estimation optimiste.</a:t>
             </a:r>
           </a:p>
           <a:p/>
           <a:p>
             <a:r>
-              <a:t>Le prix de cette prudence, c'est le rappel : 0,422 sur le jeu difficile, après être parti de 0,287. Pandas et Spark donnent exactement les mêmes résultats, et le pipeline complet, mesuré sur la même vérité terrain, aussi : précision 1,000, rappel 0,424.</a:t>
+              <a:t>Le prix de cette prudence, c'est le rappel : 0,18 sur le jeu difficile, car une fiche dont la date ou la ville a été effacée n'est jamais rattachée. Python et Spark donnent exactement les mêmes identifiants, fiche par fiche.</a:t>
             </a:r>
           </a:p>
           <a:p/>
@@ -1664,13 +1664,13 @@
           <a:p/>
           <a:p>
             <a:r>
-              <a:t>123 tests, aucun échec : moteur, gouvernance, pipeline.</a:t>
+              <a:t>131 tests, aucun échec : moteur, gouvernance, pipeline.</a:t>
             </a:r>
           </a:p>
           <a:p/>
           <a:p>
             <a:r>
-              <a:t>Précision 1,000, rappel 0,422, mêmes décisions en Pandas et en Spark.</a:t>
+              <a:t>Précision 1,000, rappel 0,179, mêmes identifiants en Python et dans Spark.</a:t>
             </a:r>
           </a:p>
           <a:p/>
@@ -1688,7 +1688,7 @@
           <a:p/>
           <a:p>
             <a:r>
-              <a:t>Les mêmes preuves en chiffres : 1 057, 803, 254.</a:t>
+              <a:t>Les mêmes preuves en chiffres : 1 057, 942, 115.</a:t>
             </a:r>
           </a:p>
           <a:p/>
@@ -1764,13 +1764,13 @@
           <a:lstStyle/>
           <a:p>
             <a:r>
-              <a:t>Je préfère nommer les limites. Le rappel sur le jeu difficile reste à 0,42. La planification automatique n'a pas encore été activée. La base centrale est une base de test, avec des consentements de démonstration. Et la plateforme n'est pas déployée : c'est un prototype reproductible.</a:t>
+              <a:t>Je préfère nommer les limites. Le rappel sur le jeu difficile est de 0,18. La planification automatique n'a pas encore été activée. La base centrale est une base de test, avec des consentements de démonstration. Et la plateforme n'est pas déployée : c'est un prototype reproductible.</a:t>
             </a:r>
           </a:p>
           <a:p/>
           <a:p>
             <a:r>
-              <a:t>La suite : terminer le consentement par type de dossier, calibrer le seuil, activer la planification. Et avant toute mise en production, vérifier le droit malgache des données de santé.</a:t>
+              <a:t>La suite : terminer le consentement par type de dossier, valider à la main les fiches incomplètes, activer la planification. Et avant toute mise en production, vérifier le droit malgache des données de santé.</a:t>
             </a:r>
           </a:p>
           <a:p/>
@@ -10164,7 +10164,7 @@
                 </a:solidFill>
                 <a:latin typeface="Calibri"/>
               </a:rPr>
-              <a:t>Déduplication explicable : jamais de fusion sans justification</a:t>
+              <a:t>Déduplication explicable : aucune fusion sans identité identique</a:t>
             </a:r>
           </a:p>
         </p:txBody>
@@ -10252,7 +10252,7 @@
                 </a:solidFill>
                 <a:latin typeface="Calibri"/>
               </a:rPr>
-              <a:t>Blocking</a:t>
+              <a:t>Clé d'identité</a:t>
             </a:r>
           </a:p>
         </p:txBody>
@@ -10287,7 +10287,7 @@
                 </a:solidFill>
                 <a:latin typeface="Calibri"/>
               </a:rPr>
-              <a:t>ne comparer que les candidats : préfixe du nom, date, CIN</a:t>
+              <a:t>CIN + genre + naissance + ville ; sans CIN, le nom en plus</a:t>
             </a:r>
           </a:p>
         </p:txBody>
@@ -10375,7 +10375,7 @@
                 </a:solidFill>
                 <a:latin typeface="Calibri"/>
               </a:rPr>
-              <a:t>Passe exacte</a:t>
+              <a:t>Règle stricte</a:t>
             </a:r>
           </a:p>
         </p:txBody>
@@ -10410,7 +10410,7 @@
                 </a:solidFill>
                 <a:latin typeface="Calibri"/>
               </a:rPr>
-              <a:t>nom normalisé + naissance + CIN identiques → score 1,0</a:t>
+              <a:t>même clé → même patient maître, sans score ni seuil</a:t>
             </a:r>
           </a:p>
         </p:txBody>
@@ -10498,7 +10498,7 @@
                 </a:solidFill>
                 <a:latin typeface="Calibri"/>
               </a:rPr>
-              <a:t>Passe probabiliste</a:t>
+              <a:t>Identité incomplète</a:t>
             </a:r>
           </a:p>
         </p:txBody>
@@ -10533,7 +10533,7 @@
                 </a:solidFill>
                 <a:latin typeface="Calibri"/>
               </a:rPr>
-              <a:t>score pondéré ≥ 0,80 → fusion ; sinon nouveau patient maître</a:t>
+              <a:t>un champ manquant → la fiche reste seule</a:t>
             </a:r>
           </a:p>
         </p:txBody>
@@ -10588,7 +10588,7 @@
                 </a:solidFill>
                 <a:latin typeface="Calibri"/>
               </a:rPr>
-              <a:t>Chaque décision porte </a:t>
+              <a:t>Chaque décision porte méthode · explication</a:t>
             </a:r>
             <a:r>
               <a:rPr sz="1600" b="1" i="0">
@@ -10597,7 +10597,7 @@
                 </a:solidFill>
                 <a:latin typeface="Calibri"/>
               </a:rPr>
-              <a:t>méthode · score · explication</a:t>
+              <a:t/>
             </a:r>
           </a:p>
           <a:p>
@@ -10609,7 +10609,7 @@
                 </a:solidFill>
                 <a:latin typeface="Consolas"/>
               </a:rPr>
-              <a:t>exact</a:t>
+              <a:t>new_master · exact — identifiant dérivé de la clé</a:t>
             </a:r>
             <a:r>
               <a:rPr sz="1600" b="0" i="0">
@@ -10618,7 +10618,7 @@
                 </a:solidFill>
                 <a:latin typeface="Calibri"/>
               </a:rPr>
-              <a:t> · </a:t>
+              <a:t/>
             </a:r>
             <a:r>
               <a:rPr sz="1500" b="0" i="0">
@@ -10627,7 +10627,7 @@
                 </a:solidFill>
                 <a:latin typeface="Consolas"/>
               </a:rPr>
-              <a:t>probabilistic</a:t>
+              <a:t/>
             </a:r>
             <a:r>
               <a:rPr sz="1600" b="0" i="0">
@@ -10636,7 +10636,7 @@
                 </a:solidFill>
                 <a:latin typeface="Calibri"/>
               </a:rPr>
-              <a:t> · </a:t>
+              <a:t/>
             </a:r>
             <a:r>
               <a:rPr sz="1500" b="0" i="0">
@@ -10645,7 +10645,7 @@
                 </a:solidFill>
                 <a:latin typeface="Consolas"/>
               </a:rPr>
-              <a:t>new_master</a:t>
+              <a:t/>
             </a:r>
           </a:p>
         </p:txBody>
@@ -10680,7 +10680,7 @@
                 </a:solidFill>
                 <a:latin typeface="Calibri"/>
               </a:rPr>
-              <a:t>Composition du score de similarité</a:t>
+              <a:t>Quatre champs comparés à l'identique</a:t>
             </a:r>
           </a:p>
         </p:txBody>
@@ -10694,7 +10694,7 @@
         <p:spPr>
           <a:xfrm>
             <a:off x="6675120" y="2103120"/>
-            <a:ext cx="2483967" cy="822960"/>
+            <a:ext cx="1241983" cy="822960"/>
           </a:xfrm>
           <a:prstGeom prst="rect">
             <a:avLst/>
@@ -10739,7 +10739,7 @@
         <p:spPr>
           <a:xfrm>
             <a:off x="6675120" y="2148840"/>
-            <a:ext cx="2483967" cy="731520"/>
+            <a:ext cx="1241983" cy="731520"/>
           </a:xfrm>
           <a:prstGeom prst="rect">
             <a:avLst/>
@@ -10760,7 +10760,7 @@
                 </a:solidFill>
                 <a:latin typeface="Calibri"/>
               </a:rPr>
-              <a:t>Nom</a:t>
+              <a:t>CIN</a:t>
             </a:r>
           </a:p>
           <a:p>
@@ -10772,7 +10772,7 @@
                 </a:solidFill>
                 <a:latin typeface="Calibri"/>
               </a:rPr>
-              <a:t>0,5</a:t>
+              <a:t>identique</a:t>
             </a:r>
           </a:p>
         </p:txBody>
@@ -10785,8 +10785,8 @@
         </p:nvSpPr>
         <p:spPr>
           <a:xfrm>
-            <a:off x="9159087" y="2103120"/>
-            <a:ext cx="1490380" cy="822960"/>
+            <a:off x="7917103" y="2103120"/>
+            <a:ext cx="1241983" cy="822960"/>
           </a:xfrm>
           <a:prstGeom prst="rect">
             <a:avLst/>
@@ -10830,8 +10830,8 @@
         </p:nvSpPr>
         <p:spPr>
           <a:xfrm>
-            <a:off x="9159087" y="2148840"/>
-            <a:ext cx="1490380" cy="731520"/>
+            <a:off x="7917103" y="2148840"/>
+            <a:ext cx="1241983" cy="731520"/>
           </a:xfrm>
           <a:prstGeom prst="rect">
             <a:avLst/>
@@ -10852,7 +10852,7 @@
                 </a:solidFill>
                 <a:latin typeface="Calibri"/>
               </a:rPr>
-              <a:t>Naissance</a:t>
+              <a:t>Genre</a:t>
             </a:r>
           </a:p>
           <a:p>
@@ -10864,7 +10864,7 @@
                 </a:solidFill>
                 <a:latin typeface="Calibri"/>
               </a:rPr>
-              <a:t>0,3</a:t>
+              <a:t>identique</a:t>
             </a:r>
           </a:p>
         </p:txBody>
@@ -10877,8 +10877,8 @@
         </p:nvSpPr>
         <p:spPr>
           <a:xfrm>
-            <a:off x="10649468" y="2103120"/>
-            <a:ext cx="496793" cy="822960"/>
+            <a:off x="9159086" y="2103120"/>
+            <a:ext cx="1241983" cy="822960"/>
           </a:xfrm>
           <a:prstGeom prst="rect">
             <a:avLst/>
@@ -10922,8 +10922,8 @@
         </p:nvSpPr>
         <p:spPr>
           <a:xfrm>
-            <a:off x="10649468" y="2148840"/>
-            <a:ext cx="496793" cy="731520"/>
+            <a:off x="9159086" y="2148840"/>
+            <a:ext cx="1241983" cy="731520"/>
           </a:xfrm>
           <a:prstGeom prst="rect">
             <a:avLst/>
@@ -10944,7 +10944,7 @@
                 </a:solidFill>
                 <a:latin typeface="Calibri"/>
               </a:rPr>
-              <a:t>CIN</a:t>
+              <a:t>Date</a:t>
             </a:r>
           </a:p>
           <a:p>
@@ -10956,7 +10956,7 @@
                 </a:solidFill>
                 <a:latin typeface="Calibri"/>
               </a:rPr>
-              <a:t>0,1</a:t>
+              <a:t>identique</a:t>
             </a:r>
           </a:p>
         </p:txBody>
@@ -10969,8 +10969,8 @@
         </p:nvSpPr>
         <p:spPr>
           <a:xfrm>
-            <a:off x="11146261" y="2103120"/>
-            <a:ext cx="496793" cy="822960"/>
+            <a:off x="10401069" y="2103120"/>
+            <a:ext cx="1241983" cy="822960"/>
           </a:xfrm>
           <a:prstGeom prst="rect">
             <a:avLst/>
@@ -11014,8 +11014,8 @@
         </p:nvSpPr>
         <p:spPr>
           <a:xfrm>
-            <a:off x="11146261" y="2148840"/>
-            <a:ext cx="496793" cy="731520"/>
+            <a:off x="10401069" y="2148840"/>
+            <a:ext cx="1241983" cy="731520"/>
           </a:xfrm>
           <a:prstGeom prst="rect">
             <a:avLst/>
@@ -11048,47 +11048,11 @@
                 </a:solidFill>
                 <a:latin typeface="Calibri"/>
               </a:rPr>
-              <a:t>0,1</a:t>
-            </a:r>
-          </a:p>
-        </p:txBody>
-      </p:sp>
-      <p:cxnSp>
-        <p:nvCxnSpPr>
-          <p:cNvPr id="29" name="Connector 28"/>
-          <p:cNvCxnSpPr/>
-          <p:nvPr/>
-        </p:nvCxnSpPr>
-        <p:spPr>
-          <a:xfrm flipV="1">
-            <a:off x="10649468" y="2971800"/>
-            <a:ext cx="0" cy="548639"/>
-          </a:xfrm>
-          <a:prstGeom prst="line">
-            <a:avLst/>
-          </a:prstGeom>
-          <a:ln w="31750">
-            <a:solidFill>
-              <a:srgbClr val="C78400"/>
-            </a:solidFill>
-            <a:tailEnd type="triangle" w="med" len="med"/>
-          </a:ln>
-        </p:spPr>
-        <p:style>
-          <a:lnRef idx="2">
-            <a:schemeClr val="accent1"/>
-          </a:lnRef>
-          <a:fillRef idx="0">
-            <a:schemeClr val="accent1"/>
-          </a:fillRef>
-          <a:effectRef idx="1">
-            <a:schemeClr val="accent1"/>
-          </a:effectRef>
-          <a:fontRef idx="minor">
-            <a:schemeClr val="tx1"/>
-          </a:fontRef>
-        </p:style>
-      </p:cxnSp>
+              <a:t>identique</a:t>
+            </a:r>
+          </a:p>
+        </p:txBody>
+      </p:sp>
       <p:sp>
         <p:nvSpPr>
           <p:cNvPr id="30" name="TextBox 29"/>
@@ -11119,7 +11083,7 @@
                 </a:solidFill>
                 <a:latin typeface="Calibri"/>
               </a:rPr>
-              <a:t>seuil de fusion : 0,80</a:t>
+              <a:t>aucun score (v1 : seuil 0,80)</a:t>
             </a:r>
           </a:p>
         </p:txBody>
@@ -11201,7 +11165,7 @@
                 </a:solidFill>
                 <a:latin typeface="Calibri"/>
               </a:rPr>
-              <a:t>EXEMPLE — CAS DE RÉFÉRENCE</a:t>
+              <a:t>EXEMPLE — 100 000 PATIENTS</a:t>
             </a:r>
           </a:p>
         </p:txBody>
@@ -11240,7 +11204,7 @@
                 </a:solidFill>
                 <a:latin typeface="Calibri"/>
               </a:rPr>
-              <a:t>Jean Rakoto</a:t>
+              <a:t>Georges Grenier ×2 : même nom, même date, CIN différents</a:t>
             </a:r>
             <a:r>
               <a:rPr sz="1500" b="0" i="0">
@@ -11249,7 +11213,7 @@
                 </a:solidFill>
                 <a:latin typeface="Calibri"/>
               </a:rPr>
-              <a:t> : 3 fiches → </a:t>
+              <a:t/>
             </a:r>
             <a:r>
               <a:rPr sz="1500" b="1" i="0">
@@ -11258,7 +11222,7 @@
                 </a:solidFill>
                 <a:latin typeface="Calibri"/>
               </a:rPr>
-              <a:t>PAT-0102</a:t>
+              <a:t/>
             </a:r>
             <a:r>
               <a:rPr sz="1500" b="0" i="0">
@@ -11267,7 +11231,7 @@
                 </a:solidFill>
                 <a:latin typeface="Calibri"/>
               </a:rPr>
-              <a:t>, méthode </a:t>
+              <a:t/>
             </a:r>
             <a:r>
               <a:rPr sz="1500" b="0" i="1">
@@ -11276,7 +11240,7 @@
                 </a:solidFill>
                 <a:latin typeface="Calibri"/>
               </a:rPr>
-              <a:t>exacte</a:t>
+              <a:t/>
             </a:r>
             <a:r>
               <a:rPr sz="1500" b="0" i="0">
@@ -11285,7 +11249,7 @@
                 </a:solidFill>
                 <a:latin typeface="Calibri"/>
               </a:rPr>
-              <a:t> (CIN identique après normalisation)</a:t>
+              <a:t/>
             </a:r>
           </a:p>
           <a:p>
@@ -11301,7 +11265,7 @@
                 </a:solidFill>
                 <a:latin typeface="Calibri"/>
               </a:rPr>
-              <a:t>Nirina</a:t>
+              <a:t>v1 (score 0,80) : fusion à tort — v2 : deux patients distincts</a:t>
             </a:r>
             <a:r>
               <a:rPr sz="1500" b="0" i="0">
@@ -11310,7 +11274,7 @@
                 </a:solidFill>
                 <a:latin typeface="Calibri"/>
               </a:rPr>
-              <a:t> : rattachée par méthode </a:t>
+              <a:t/>
             </a:r>
             <a:r>
               <a:rPr sz="1500" b="0" i="1">
@@ -11319,7 +11283,7 @@
                 </a:solidFill>
                 <a:latin typeface="Calibri"/>
               </a:rPr>
-              <a:t>probabiliste</a:t>
+              <a:t/>
             </a:r>
             <a:r>
               <a:rPr sz="1500" b="0" i="0">
@@ -11328,7 +11292,7 @@
                 </a:solidFill>
                 <a:latin typeface="Calibri"/>
               </a:rPr>
-              <a:t>, score ≥ 0,80</a:t>
+              <a:t/>
             </a:r>
           </a:p>
         </p:txBody>
@@ -12844,7 +12808,7 @@
                 </a:solidFill>
                 <a:latin typeface="Calibri"/>
               </a:rPr>
-              <a:t>Sur le jeu difficile : 1 057 fiches ramenées à 803 patients</a:t>
+              <a:t>Sur le jeu difficile : 1 057 fiches ramenées à 942 patients</a:t>
             </a:r>
           </a:p>
         </p:txBody>
@@ -13089,7 +13053,7 @@
                 </a:solidFill>
                 <a:latin typeface="Calibri"/>
               </a:rPr>
-              <a:t>803</a:t>
+              <a:t>942</a:t>
             </a:r>
           </a:p>
         </p:txBody>
@@ -13206,7 +13170,7 @@
                 </a:solidFill>
                 <a:latin typeface="Calibri"/>
               </a:rPr>
-              <a:t>254</a:t>
+              <a:t>115</a:t>
             </a:r>
           </a:p>
         </p:txBody>
@@ -13323,7 +13287,7 @@
                 </a:solidFill>
                 <a:latin typeface="Calibri"/>
               </a:rPr>
-              <a:t>24,03 %</a:t>
+              <a:t>10,88 %</a:t>
             </a:r>
           </a:p>
         </p:txBody>
@@ -13393,7 +13357,7 @@
                 </a:solidFill>
                 <a:latin typeface="Calibri"/>
               </a:rPr>
-              <a:t>1 057 − 254 = 803</a:t>
+              <a:t>1 057 − 115 = 942</a:t>
             </a:r>
           </a:p>
         </p:txBody>
@@ -13498,7 +13462,7 @@
                 </a:solidFill>
                 <a:latin typeface="Calibri"/>
               </a:rPr>
-              <a:t>étapes du pipeline réussies (run du 29/09/2026)</a:t>
+              <a:t>étapes du pipeline réussies (run du 30/09/2026)</a:t>
             </a:r>
           </a:p>
         </p:txBody>
@@ -13533,7 +13497,7 @@
                 </a:solidFill>
                 <a:latin typeface="Calibri"/>
               </a:rPr>
-              <a:t>123 / 123</a:t>
+              <a:t>131 / 131</a:t>
             </a:r>
           </a:p>
         </p:txBody>
@@ -14007,7 +13971,7 @@
                 </a:solidFill>
                 <a:latin typeface="Calibri"/>
               </a:rPr>
-              <a:t>faux positif sur les trois niveaux</a:t>
+              <a:t>faux positif sur tous les jeux, 100 000 patients compris</a:t>
             </a:r>
           </a:p>
         </p:txBody>
@@ -14093,7 +14057,7 @@
                 </a:solidFill>
                 <a:latin typeface="Calibri"/>
               </a:rPr>
-              <a:t>Parité Pandas = Spark</a:t>
+              <a:t>Parité Python = Spark</a:t>
             </a:r>
           </a:p>
           <a:p>
@@ -14109,7 +14073,7 @@
                 </a:solidFill>
                 <a:latin typeface="Calibri"/>
               </a:rPr>
-              <a:t>VP 307 · FP 0 · FN 420 dans les deux implémentations</a:t>
+              <a:t>0 différence d'identifiant sur 212 523 fiches</a:t>
             </a:r>
           </a:p>
         </p:txBody>
@@ -14195,7 +14159,7 @@
                 </a:solidFill>
                 <a:latin typeface="Calibri"/>
               </a:rPr>
-              <a:t>Rappel difficile : 0,287 → 0,422</a:t>
+              <a:t>Rappel difficile : 0,422 (v1) → 0,179 (v2)</a:t>
             </a:r>
           </a:p>
           <a:p>
@@ -14211,7 +14175,7 @@
                 </a:solidFill>
                 <a:latin typeface="Calibri"/>
               </a:rPr>
-              <a:t>grâce au CIN dans la clé exacte, sans aucun faux positif</a:t>
+              <a:t>prix de la règle stricte : fiches incomplètes non rattachées</a:t>
             </a:r>
           </a:p>
         </p:txBody>
@@ -14744,7 +14708,7 @@
                 </a:solidFill>
                 <a:latin typeface="Calibri"/>
               </a:rPr>
-              <a:t>Tests automatisés : 123 / 123</a:t>
+              <a:t>Tests automatisés : 131 / 131</a:t>
             </a:r>
           </a:p>
         </p:txBody>
@@ -15104,7 +15068,7 @@
                 </a:solidFill>
                 <a:latin typeface="Calibri"/>
               </a:rPr>
-              <a:t>Repli : compteurs figés 1 057 · 803 · 254</a:t>
+              <a:t>Repli : compteurs figés 1 057 · 942 · 115</a:t>
             </a:r>
           </a:p>
         </p:txBody>
@@ -15498,7 +15462,7 @@
                 </a:solidFill>
                 <a:latin typeface="Calibri"/>
               </a:rPr>
-              <a:t>Rappel de </a:t>
+              <a:t>Rappel de 0,179 sur le jeu difficile (fiches incomplètes)</a:t>
             </a:r>
             <a:r>
               <a:rPr sz="1600" b="1" i="0">
@@ -15507,7 +15471,7 @@
                 </a:solidFill>
                 <a:latin typeface="Calibri"/>
               </a:rPr>
-              <a:t>0,422</a:t>
+              <a:t/>
             </a:r>
             <a:r>
               <a:rPr sz="1600" b="0" i="0">
@@ -15516,7 +15480,7 @@
                 </a:solidFill>
                 <a:latin typeface="Calibri"/>
               </a:rPr>
-              <a:t> sur le jeu difficile (seuil prudent)</a:t>
+              <a:t/>
             </a:r>
           </a:p>
           <a:p>
@@ -15536,7 +15500,7 @@
                 </a:solidFill>
                 <a:latin typeface="Calibri"/>
               </a:rPr>
-              <a:t>Planification </a:t>
+              <a:t>Planification cron non activée : logique testée, pas encore observée</a:t>
             </a:r>
             <a:r>
               <a:rPr sz="1600" b="1" i="0">
@@ -15545,7 +15509,7 @@
                 </a:solidFill>
                 <a:latin typeface="Calibri"/>
               </a:rPr>
-              <a:t>cron non activée</a:t>
+              <a:t/>
             </a:r>
             <a:r>
               <a:rPr sz="1600" b="0" i="0">
@@ -15554,7 +15518,7 @@
                 </a:solidFill>
                 <a:latin typeface="Calibri"/>
               </a:rPr>
-              <a:t> : logique testée, pas encore observée</a:t>
+              <a:t/>
             </a:r>
           </a:p>
           <a:p>
@@ -15574,7 +15538,7 @@
                 </a:solidFill>
                 <a:latin typeface="Calibri"/>
               </a:rPr>
-              <a:t>Base centrale </a:t>
+              <a:t>Base centrale de test : consentements de démonstration</a:t>
             </a:r>
             <a:r>
               <a:rPr sz="1600" b="1" i="0">
@@ -15583,7 +15547,7 @@
                 </a:solidFill>
                 <a:latin typeface="Calibri"/>
               </a:rPr>
-              <a:t>de test</a:t>
+              <a:t/>
             </a:r>
             <a:r>
               <a:rPr sz="1600" b="0" i="0">
@@ -15592,7 +15556,7 @@
                 </a:solidFill>
                 <a:latin typeface="Calibri"/>
               </a:rPr>
-              <a:t> : consentements de démonstration</a:t>
+              <a:t/>
             </a:r>
           </a:p>
           <a:p>
@@ -15612,7 +15576,7 @@
                 </a:solidFill>
                 <a:latin typeface="Calibri"/>
               </a:rPr>
-              <a:t>Plateforme </a:t>
+              <a:t>Plateforme non déployée : prototype reproductible sur VM</a:t>
             </a:r>
             <a:r>
               <a:rPr sz="1600" b="1" i="0">
@@ -15621,7 +15585,7 @@
                 </a:solidFill>
                 <a:latin typeface="Calibri"/>
               </a:rPr>
-              <a:t>non déployée</a:t>
+              <a:t/>
             </a:r>
             <a:r>
               <a:rPr sz="1600" b="0" i="0">
@@ -15630,7 +15594,7 @@
                 </a:solidFill>
                 <a:latin typeface="Calibri"/>
               </a:rPr>
-              <a:t> : prototype reproductible sur VM</a:t>
+              <a:t/>
             </a:r>
           </a:p>
         </p:txBody>
@@ -15755,7 +15719,7 @@
                 </a:solidFill>
                 <a:latin typeface="Calibri"/>
               </a:rPr>
-              <a:t>Court terme</a:t>
+              <a:t>Court terme : consentement par type de dossier, validation des fiches incomplètes, activation du cron</a:t>
             </a:r>
             <a:r>
               <a:rPr sz="1600" b="0" i="0">
@@ -15764,7 +15728,7 @@
                 </a:solidFill>
                 <a:latin typeface="Calibri"/>
               </a:rPr>
-              <a:t> : consentement par type de dossier, calibrage du seuil, activation du cron</a:t>
+              <a:t/>
             </a:r>
           </a:p>
           <a:p>
@@ -15784,7 +15748,7 @@
                 </a:solidFill>
                 <a:latin typeface="Calibri"/>
               </a:rPr>
-              <a:t>Moyen terme</a:t>
+              <a:t>Moyen terme : intégration continue, lignes nouvelles seules, plusieurs nœuds</a:t>
             </a:r>
             <a:r>
               <a:rPr sz="1600" b="0" i="0">
@@ -15793,7 +15757,7 @@
                 </a:solidFill>
                 <a:latin typeface="Calibri"/>
               </a:rPr>
-              <a:t> : intégration continue, blocking partitionné, volumes réels</a:t>
+              <a:t/>
             </a:r>
           </a:p>
           <a:p>
@@ -15813,7 +15777,7 @@
                 </a:solidFill>
                 <a:latin typeface="Calibri"/>
               </a:rPr>
-              <a:t>Long terme</a:t>
+              <a:t>Long terme : catalogue de métadonnées, autres entités (médecins, médicaments)</a:t>
             </a:r>
             <a:r>
               <a:rPr sz="1600" b="0" i="0">
@@ -15822,7 +15786,7 @@
                 </a:solidFill>
                 <a:latin typeface="Calibri"/>
               </a:rPr>
-              <a:t> : catalogue de métadonnées, autres entités (médecins, médicaments)</a:t>
+              <a:t/>
             </a:r>
           </a:p>
         </p:txBody>

</xml_diff>

<commit_message>
feat: Update dependencies and enhance governance pipeline
- Updated requirements to include PyYAML and psycopg with connection pooling.
- Enhanced bootstrap script to log Spark events and configure event logging.
- Added new analytics view for gold events based on patient consent.
- Improved age tranche handling in gold data processing with a new utility.
- Added tests for age tranche logic and governance API interactions with PostgreSQL.
- Created indexes in the database schema for improved query performance.
</commit_message>
<xml_diff>
--- a/documents/slide_soutenance/Soutenance_M2_MBDS_RANOMENJANAHARY.pptx
+++ b/documents/slide_soutenance/Soutenance_M2_MBDS_RANOMENJANAHARY.pptx
@@ -325,13 +325,13 @@
                 <c:formatCode>General</c:formatCode>
                 <c:ptCount val="3"/>
                 <c:pt idx="0">
-                  <c:v>1.0</c:v>
+                  <c:v>1</c:v>
                 </c:pt>
                 <c:pt idx="1">
-                  <c:v>1.0</c:v>
+                  <c:v>1</c:v>
                 </c:pt>
                 <c:pt idx="2">
-                  <c:v>1.0</c:v>
+                  <c:v>1</c:v>
                 </c:pt>
               </c:numCache>
             </c:numRef>
@@ -517,13 +517,13 @@
                 <c:formatCode>General</c:formatCode>
                 <c:ptCount val="3"/>
                 <c:pt idx="0">
-                  <c:v>1.0</c:v>
+                  <c:v>1</c:v>
                 </c:pt>
                 <c:pt idx="1">
-                  <c:v>0.824</c:v>
+                  <c:v>0.82399999999999995</c:v>
                 </c:pt>
                 <c:pt idx="2">
-                  <c:v>0.179</c:v>
+                  <c:v>0.17899999999999999</c:v>
                 </c:pt>
               </c:numCache>
             </c:numRef>
@@ -709,13 +709,13 @@
                 <c:formatCode>General</c:formatCode>
                 <c:ptCount val="3"/>
                 <c:pt idx="0">
-                  <c:v>1.0</c:v>
+                  <c:v>1</c:v>
                 </c:pt>
                 <c:pt idx="1">
-                  <c:v>0.903</c:v>
+                  <c:v>0.90300000000000002</c:v>
                 </c:pt>
                 <c:pt idx="2">
-                  <c:v>0.303</c:v>
+                  <c:v>0.30299999999999999</c:v>
                 </c:pt>
               </c:numCache>
             </c:numRef>
@@ -1014,13 +1014,252 @@
           <a:lstStyle/>
           <a:p>
             <a:r>
-              <a:t>Bonjour à toutes et à tous. Je suis Ranomenjanahary Manjaka Alpha, en master MBDS. Je vais vous présenter mon stage chez Madagascar Medical Technology : une plateforme qui rassemble les dossiers d'un même patient dispersés entre plusieurs services, et qui ne laisse lire ces dossiers que si le patient l'a accepté. Toutes les données que je vais montrer sont fictives.</a:t>
-            </a:r>
-          </a:p>
-          <a:p/>
-          <a:p>
-            <a:r>
-              <a:t>→ Quelques mots d'abord sur l'entreprise qui m'a accueilli.</a:t>
+              <a:rPr lang="en-US" dirty="0"/>
+              <a:t>Merci </a:t>
+            </a:r>
+            <a:r>
+              <a:rPr lang="en-US" dirty="0" err="1"/>
+              <a:t>Mr</a:t>
+            </a:r>
+            <a:r>
+              <a:rPr lang="en-US" dirty="0"/>
+              <a:t> le Jury de </a:t>
+            </a:r>
+            <a:r>
+              <a:rPr lang="en-US" dirty="0" err="1"/>
+              <a:t>m’avoir</a:t>
+            </a:r>
+            <a:r>
+              <a:rPr lang="en-US" dirty="0"/>
+              <a:t> donner la </a:t>
+            </a:r>
+            <a:r>
+              <a:rPr lang="en-US"/>
+              <a:t>parole. </a:t>
+            </a:r>
+            <a:r>
+              <a:t>Je </a:t>
+            </a:r>
+            <a:r>
+              <a:rPr dirty="0"/>
+              <a:t>suis Ranomenjanahary Manjaka Alpha, </a:t>
+            </a:r>
+            <a:r>
+              <a:rPr dirty="0" err="1"/>
+              <a:t>en</a:t>
+            </a:r>
+            <a:r>
+              <a:rPr dirty="0"/>
+              <a:t> master MBDS. Je </a:t>
+            </a:r>
+            <a:r>
+              <a:rPr dirty="0" err="1"/>
+              <a:t>vais</a:t>
+            </a:r>
+            <a:r>
+              <a:rPr dirty="0"/>
+              <a:t> vous </a:t>
+            </a:r>
+            <a:r>
+              <a:rPr dirty="0" err="1"/>
+              <a:t>présenter</a:t>
+            </a:r>
+            <a:r>
+              <a:rPr dirty="0"/>
+              <a:t> </a:t>
+            </a:r>
+            <a:r>
+              <a:rPr dirty="0" err="1"/>
+              <a:t>mon</a:t>
+            </a:r>
+            <a:r>
+              <a:rPr dirty="0"/>
+              <a:t> stage chez Madagascar Medical Technology : </a:t>
+            </a:r>
+            <a:r>
+              <a:rPr dirty="0" err="1"/>
+              <a:t>une</a:t>
+            </a:r>
+            <a:r>
+              <a:rPr dirty="0"/>
+              <a:t> </a:t>
+            </a:r>
+            <a:r>
+              <a:rPr dirty="0" err="1"/>
+              <a:t>plateforme</a:t>
+            </a:r>
+            <a:r>
+              <a:rPr dirty="0"/>
+              <a:t> qui </a:t>
+            </a:r>
+            <a:r>
+              <a:rPr dirty="0" err="1"/>
+              <a:t>rassemble</a:t>
+            </a:r>
+            <a:r>
+              <a:rPr dirty="0"/>
+              <a:t> les dossiers d'un </a:t>
+            </a:r>
+            <a:r>
+              <a:rPr dirty="0" err="1"/>
+              <a:t>même</a:t>
+            </a:r>
+            <a:r>
+              <a:rPr dirty="0"/>
+              <a:t> patient </a:t>
+            </a:r>
+            <a:r>
+              <a:rPr dirty="0" err="1"/>
+              <a:t>dispersés</a:t>
+            </a:r>
+            <a:r>
+              <a:rPr dirty="0"/>
+              <a:t> entre </a:t>
+            </a:r>
+            <a:r>
+              <a:rPr dirty="0" err="1"/>
+              <a:t>plusieurs</a:t>
+            </a:r>
+            <a:r>
+              <a:rPr dirty="0"/>
+              <a:t> services, et qui ne laisse lire </a:t>
+            </a:r>
+            <a:r>
+              <a:rPr dirty="0" err="1"/>
+              <a:t>ces</a:t>
+            </a:r>
+            <a:r>
+              <a:rPr dirty="0"/>
+              <a:t> dossiers </a:t>
+            </a:r>
+            <a:r>
+              <a:rPr dirty="0" err="1"/>
+              <a:t>que</a:t>
+            </a:r>
+            <a:r>
+              <a:rPr dirty="0"/>
+              <a:t> </a:t>
+            </a:r>
+            <a:r>
+              <a:rPr dirty="0" err="1"/>
+              <a:t>si</a:t>
+            </a:r>
+            <a:r>
+              <a:rPr dirty="0"/>
+              <a:t> le patient </a:t>
+            </a:r>
+            <a:r>
+              <a:rPr dirty="0" err="1"/>
+              <a:t>l'a</a:t>
+            </a:r>
+            <a:r>
+              <a:rPr dirty="0"/>
+              <a:t> </a:t>
+            </a:r>
+            <a:r>
+              <a:rPr dirty="0" err="1"/>
+              <a:t>accepté</a:t>
+            </a:r>
+            <a:r>
+              <a:rPr dirty="0"/>
+              <a:t>. </a:t>
+            </a:r>
+            <a:r>
+              <a:rPr dirty="0" err="1"/>
+              <a:t>Toutes</a:t>
+            </a:r>
+            <a:r>
+              <a:rPr dirty="0"/>
+              <a:t> les données </a:t>
+            </a:r>
+            <a:r>
+              <a:rPr dirty="0" err="1"/>
+              <a:t>que</a:t>
+            </a:r>
+            <a:r>
+              <a:rPr dirty="0"/>
+              <a:t> je </a:t>
+            </a:r>
+            <a:r>
+              <a:rPr dirty="0" err="1"/>
+              <a:t>vais</a:t>
+            </a:r>
+            <a:r>
+              <a:rPr dirty="0"/>
+              <a:t> </a:t>
+            </a:r>
+            <a:r>
+              <a:rPr dirty="0" err="1"/>
+              <a:t>montrer</a:t>
+            </a:r>
+            <a:r>
+              <a:rPr dirty="0"/>
+              <a:t> </a:t>
+            </a:r>
+            <a:r>
+              <a:rPr dirty="0" err="1"/>
+              <a:t>sont</a:t>
+            </a:r>
+            <a:r>
+              <a:rPr dirty="0"/>
+              <a:t> </a:t>
+            </a:r>
+            <a:r>
+              <a:rPr dirty="0" err="1"/>
+              <a:t>fictives</a:t>
+            </a:r>
+            <a:r>
+              <a:rPr dirty="0"/>
+              <a:t>.</a:t>
+            </a:r>
+          </a:p>
+          <a:p>
+            <a:endParaRPr dirty="0"/>
+          </a:p>
+          <a:p>
+            <a:r>
+              <a:rPr dirty="0"/>
+              <a:t>→ </a:t>
+            </a:r>
+            <a:r>
+              <a:rPr dirty="0" err="1"/>
+              <a:t>Quelques</a:t>
+            </a:r>
+            <a:r>
+              <a:rPr dirty="0"/>
+              <a:t> mots </a:t>
+            </a:r>
+            <a:r>
+              <a:rPr dirty="0" err="1"/>
+              <a:t>d'abord</a:t>
+            </a:r>
+            <a:r>
+              <a:rPr dirty="0"/>
+              <a:t> sur </a:t>
+            </a:r>
+            <a:r>
+              <a:rPr dirty="0" err="1"/>
+              <a:t>l'entreprise</a:t>
+            </a:r>
+            <a:r>
+              <a:rPr dirty="0"/>
+              <a:t> qui </a:t>
+            </a:r>
+            <a:r>
+              <a:rPr dirty="0" err="1"/>
+              <a:t>m'a</a:t>
+            </a:r>
+            <a:r>
+              <a:rPr dirty="0"/>
+              <a:t> </a:t>
+            </a:r>
+            <a:r>
+              <a:rPr dirty="0" err="1"/>
+              <a:t>accueilli</a:t>
+            </a:r>
+            <a:r>
+              <a:rPr dirty="0"/>
+              <a:t>.</a:t>
             </a:r>
           </a:p>
         </p:txBody>
@@ -1093,7 +1332,9 @@
               <a:t>Pas d'identifiant commun : le CIN manque pour environ un quart des patients. Pas de format commun. Pas de rapprochement explicable. Pas de gouvernance. Et pas d'espace pour rejouer un traitement. Le premier prototype comptait 24 872 marqueurs de doublon, mais sans jamais dire pourquoi : on détectait, on n'expliquait pas.</a:t>
             </a:r>
           </a:p>
-          <a:p/>
+          <a:p>
+            <a:endParaRPr/>
+          </a:p>
           <a:p>
             <a:r>
               <a:t>→ Ma réponse a commencé petit.</a:t>
@@ -1169,13 +1410,17 @@
               <a:t>Je n'ai pas commencé par le Big Data. Niveau 1 : un prototype simple, en Pandas et PostgreSQL, pour vérifier que le problème métier se résout. Niveau 2 : le même moteur porté en Spark, avec des résultats strictement identiques. Niveau 3 : le lac de données sur HDFS, Hive et Spark.</a:t>
             </a:r>
           </a:p>
-          <a:p/>
+          <a:p>
+            <a:endParaRPr/>
+          </a:p>
           <a:p>
             <a:r>
               <a:t>Deux garde-fous : je n'ai changé d'échelle qu'après avoir validé la qualité sur une vérité terrain, et je n'ai ouvert les accès qu'une fois la gouvernance en place. Chaque technologie arrive parce qu'un besoin l'exige.</a:t>
             </a:r>
           </a:p>
-          <a:p/>
+          <a:p>
+            <a:endParaRPr/>
+          </a:p>
           <a:p>
             <a:r>
               <a:t>→ Voici le chemin d'une donnée dans l'architecture finale.</a:t>
@@ -1251,7 +1496,9 @@
               <a:t>Les sources sont copiées telles quelles dans la zone RAW, sur HDFS. Elles sont ensuite harmonisées au format FHIR dans la zone SILVER, où le moteur rattache chaque fiche à son patient maître. La zone GOLD porte les agrégats et le consentement. PostgreSQL garde l'état de référence : patients maîtres, consentements, journal d'audit. Et l'API de gouvernance est la seule porte d'entrée : chaque appel y est journalisé. Le tout tourne sur une machine virtuelle de 8 Go, avec des outils libres.</a:t>
             </a:r>
           </a:p>
-          <a:p/>
+          <a:p>
+            <a:endParaRPr/>
+          </a:p>
           <a:p>
             <a:r>
               <a:t>→ Le cœur de cette architecture, c'est le moteur de déduplication.</a:t>
@@ -1327,19 +1574,25 @@
               <a:t>Sa règle tient en une phrase : aucune fusion sans identité identique.</a:t>
             </a:r>
           </a:p>
-          <a:p/>
+          <a:p>
+            <a:endParaRPr/>
+          </a:p>
           <a:p>
             <a:r>
               <a:t>Deux fiches sont réunies si, et seulement si, elles ont le même CIN, le même genre, la même date et la même ville de naissance. Sans CIN, le nom doit être identique en plus. Il n'y a ni score ni seuil : qu'un champ manque, et la fiche reste seule.</a:t>
             </a:r>
           </a:p>
-          <a:p/>
+          <a:p>
+            <a:endParaRPr/>
+          </a:p>
           <a:p>
             <a:r>
               <a:t>J'ai d'abord utilisé un score pondéré. Sur 100 000 patients, il a réuni deux homonymes parfaits, aux CIN différents. J'ai donc choisi la règle stricte. Chaque décision porte sa méthode et son explication, et l'identifiant du patient, dérivé de sa clé, ne change pas d'un run à l'autre.</a:t>
             </a:r>
           </a:p>
-          <a:p/>
+          <a:p>
+            <a:endParaRPr/>
+          </a:p>
           <a:p>
             <a:r>
               <a:t>→ Une fois l'identité établie, reste à savoir qui peut la lire.</a:t>
@@ -1415,13 +1668,17 @@
               <a:t>Trois contrôles, dans cet ordre. Qui demande ? La clé d'API donne l'utilisateur et son rôle ; une clé inconnue, c'est 401. Pourquoi ? La finalité est obligatoire ; si le patient ne l'a pas acceptée, c'est 403, même pour un utilisateur autorisé. Et la trace : chaque appel, accepté ou refusé, est journalisé avec son motif.</a:t>
             </a:r>
           </a:p>
-          <a:p/>
+          <a:p>
+            <a:endParaRPr/>
+          </a:p>
           <a:p>
             <a:r>
               <a:t>Aujourd'hui, le patient choisit par finalité : consultation via l'API, recherche, statistiques. L'étape suivante, en cours de développement, c'est le choix par type de dossier : accepter qu'on lise ses consultations, mais refuser l'imagerie.</a:t>
             </a:r>
           </a:p>
-          <a:p/>
+          <a:p>
+            <a:endParaRPr/>
+          </a:p>
           <a:p>
             <a:r>
               <a:t>→ Qu'est-ce que tout cela donne sur des données ?</a:t>
@@ -1497,7 +1754,9 @@
               <a:t>Sur le jeu difficile, rejoué dans la VM : 1 057 fiches, 942 patients distincts, 115 doublons rattachés. La cohérence se vérifie par une soustraction : 1 057 moins 115, 942. Sur 100 000 patients, le run complet prend moins de trois minutes. Et les 131 tests passent.</a:t>
             </a:r>
           </a:p>
-          <a:p/>
+          <a:p>
+            <a:endParaRPr/>
+          </a:p>
           <a:p>
             <a:r>
               <a:t>→ Mais ces 942 patients sont-ils les bons ?</a:t>
@@ -1573,19 +1832,25 @@
               <a:t>Pour le savoir, il faut connaître la vérité. J'ai donc généré des patients fictifs, puis des jeux où 10, 30 ou 50 % des fiches sont abîmées : fautes de frappe, inversions, champs effacés.</a:t>
             </a:r>
           </a:p>
-          <a:p/>
+          <a:p>
+            <a:endParaRPr/>
+          </a:p>
           <a:p>
             <a:r>
               <a:t>Résultat principal : zéro fusion à tort, sur tous les jeux, y compris à 100 000 patients. En santé, c'est la propriété qui compte : confondre deux patients est plus grave que de les laisser séparés. Sa portée a une limite : mes données ne contiennent pas de CIN partagé par deux personnes. C'est donc une estimation optimiste.</a:t>
             </a:r>
           </a:p>
-          <a:p/>
+          <a:p>
+            <a:endParaRPr/>
+          </a:p>
           <a:p>
             <a:r>
               <a:t>Le prix de cette prudence, c'est le rappel : 0,18 sur le jeu difficile, car une fiche dont la date ou la ville a été effacée n'est jamais rattachée. Python et Spark donnent exactement les mêmes identifiants, fiche par fiche.</a:t>
             </a:r>
           </a:p>
-          <a:p/>
+          <a:p>
+            <a:endParaRPr/>
+          </a:p>
           <a:p>
             <a:r>
               <a:t>→ Je vous montre maintenant la chaîne en fonctionnement.</a:t>
@@ -1661,37 +1926,49 @@
               <a:t>La vidéo suit l'ordre de construction du projet : les tests, l'évaluation, le pipeline, puis le tableau de bord.</a:t>
             </a:r>
           </a:p>
-          <a:p/>
+          <a:p>
+            <a:endParaRPr/>
+          </a:p>
           <a:p>
             <a:r>
               <a:t>131 tests, aucun échec : moteur, gouvernance, pipeline.</a:t>
             </a:r>
           </a:p>
-          <a:p/>
+          <a:p>
+            <a:endParaRPr/>
+          </a:p>
           <a:p>
             <a:r>
               <a:t>Précision 1,000, rappel 0,179, mêmes identifiants en Python et dans Spark.</a:t>
             </a:r>
           </a:p>
-          <a:p/>
+          <a:p>
+            <a:endParaRPr/>
+          </a:p>
           <a:p>
             <a:r>
               <a:t>Les étapes s'enchaînent jusqu'à la zone GOLD.</a:t>
             </a:r>
           </a:p>
-          <a:p/>
+          <a:p>
+            <a:endParaRPr/>
+          </a:p>
           <a:p>
             <a:r>
               <a:t>Les zones, le dernier run et la planification.</a:t>
             </a:r>
           </a:p>
-          <a:p/>
+          <a:p>
+            <a:endParaRPr/>
+          </a:p>
           <a:p>
             <a:r>
               <a:t>Les mêmes preuves en chiffres : 1 057, 942, 115.</a:t>
             </a:r>
           </a:p>
-          <a:p/>
+          <a:p>
+            <a:endParaRPr/>
+          </a:p>
           <a:p>
             <a:r>
               <a:t>→ Ce que je n'ai pas résolu.</a:t>
@@ -1767,13 +2044,17 @@
               <a:t>Je préfère nommer les limites. Le rappel sur le jeu difficile est de 0,18. La planification automatique n'a pas encore été activée. La base centrale est une base de test, avec des consentements de démonstration. Et la plateforme n'est pas déployée : c'est un prototype reproductible.</a:t>
             </a:r>
           </a:p>
-          <a:p/>
+          <a:p>
+            <a:endParaRPr/>
+          </a:p>
           <a:p>
             <a:r>
               <a:t>La suite : terminer le consentement par type de dossier, valider à la main les fiches incomplètes, activer la planification. Et avant toute mise en production, vérifier le droit malgache des données de santé.</a:t>
             </a:r>
           </a:p>
-          <a:p/>
+          <a:p>
+            <a:endParaRPr/>
+          </a:p>
           <a:p>
             <a:r>
               <a:t>→ Pour conclure.</a:t>
@@ -1919,13 +2200,17 @@
               <a:t>MMT a été créée en 2009. Son métier historique, c'est le matériel biomédical : distribution, maintenance, consommables. Elle est Business Partner de Siemens Healthineers. Depuis 2024, elle a un département Recherche et Développement, qui gère des systèmes d'information médicale : c'est là que j'ai passé quatre mois, de juillet à fin octobre.</a:t>
             </a:r>
           </a:p>
-          <a:p/>
+          <a:p>
+            <a:endParaRPr/>
+          </a:p>
           <a:p>
             <a:r>
               <a:t>J'ai choisi ce sujet parce qu'il réunit les trois volets du master : les bases de données, l'intégration de systèmes hétérogènes et le Big Data, que je voulais pratiquer et non plus seulement étudier.</a:t>
             </a:r>
           </a:p>
-          <a:p/>
+          <a:p>
+            <a:endParaRPr/>
+          </a:p>
           <a:p>
             <a:r>
               <a:t>→ Voici le problème que j'ai trouvé en arrivant.</a:t>
@@ -2071,13 +2356,17 @@
               <a:t>Imaginez un patient. Il passe à la pharmacie, puis en consultation, puis à l'imagerie. À chaque étape, on l'enregistre de nouveau. En pharmacie, il s'appelle « Jean Rakoto ». En consultation, « Rakoto Jean ». À l'imagerie, « J. RAKOTO ». Le CIN et la date de naissance sont écrits autrement à chaque fois.</a:t>
             </a:r>
           </a:p>
-          <a:p/>
+          <a:p>
+            <a:endParaRPr/>
+          </a:p>
           <a:p>
             <a:r>
               <a:t>Aucun de ces services ne sait que c'est la même personne. Et personne ne lui a demandé ce qu'il accepte que l'on fasse de ses données. Voilà les deux questions de mon stage : comment savoir que c'est lui ? Et qui a le droit de lire son dossier, pour quoi faire ?</a:t>
             </a:r>
           </a:p>
-          <a:p/>
+          <a:p>
+            <a:endParaRPr/>
+          </a:p>
           <a:p>
             <a:r>
               <a:t>→ Derrière ce cas, il y a trois problèmes.</a:t>
@@ -2153,13 +2442,17 @@
               <a:t>Le premier, c'est la dispersion : le dossier d'un patient est éclaté entre plusieurs bases. Le deuxième, l'hétérogénéité : même le genre s'écrit H/F, male/female ou Homme/femme. Et ces sources ne sont pas figées : un service peut être séparé en plusieurs bases demain. Le troisième, l'absence de gouvernance : rien ne dit qui accède à quoi, ni pourquoi.</a:t>
             </a:r>
           </a:p>
-          <a:p/>
+          <a:p>
+            <a:endParaRPr/>
+          </a:p>
           <a:p>
             <a:r>
               <a:t>Ma problématique est donc la suivante : comment centraliser et dédupliquer ces données, tout en gardant la trace des identités et en contrôlant chaque accès par le consentement du patient ?</a:t>
             </a:r>
           </a:p>
-          <a:p/>
+          <a:p>
+            <a:endParaRPr/>
+          </a:p>
           <a:p>
             <a:r>
               <a:t>→ Le cahier des charges traduit cela en six objectifs.</a:t>
@@ -2375,7 +2668,9 @@
               <a:t>Quatre notions structurent tout le projet. L'ELT : on charge la donnée brute d'abord, on la transforme ensuite. Le modèle Medallion : trois zones de qualité croissante, RAW, SILVER et GOLD, qu'on peut rejouer. Le Master Patient Index : l'annuaire qui reconnaît un même patient et lui donne un identifiant unique. Et le consentement par finalité : le patient autorise un usage précis, jamais un accès global. Sans avis de sa part, c'est un refus.</a:t>
             </a:r>
           </a:p>
-          <a:p/>
+          <a:p>
+            <a:endParaRPr/>
+          </a:p>
           <a:p>
             <a:r>
               <a:t>→ Existe-t-il déjà un produit qui fasse tout cela ?</a:t>
@@ -2451,13 +2746,17 @@
               <a:t>J'ai comparé six solutions sur six critères, à partir de leur documentation : je ne les ai pas installées. Les plus complètes sur l'identité, comme EMPI ou Talend, sont lourdes et sous licence. Azure est un service cloud, donc exclu par l'hébergement interne. Splink est excellent sur l'algorithme, mais ses poids sont difficiles à expliquer à un gestionnaire de données.</a:t>
             </a:r>
           </a:p>
-          <a:p/>
+          <a:p>
+            <a:endParaRPr/>
+          </a:p>
           <a:p>
             <a:r>
               <a:t>Aucune ne coche les six critères. J'ai donc construit une chaîne sur mesure, mais adossée aux standards : Fellegi-Sunter pour la décision, FHIR pour le format, Medallion pour le lac.</a:t>
             </a:r>
           </a:p>
-          <a:p/>
+          <a:p>
+            <a:endParaRPr/>
+          </a:p>
           <a:p>
             <a:r>
               <a:t>→ Côté établissement, qu'est-ce qui existait ?</a:t>
@@ -2533,7 +2832,9 @@
               <a:t>Trois systèmes : MAVIS, sous Odoo, avec 1 260 tables sur le serveur distant ; MMT_DB, sous GNU Health ; et une base clinique en SQLite. Chacune est cohérente avec elle-même : la clinique n'a aucune violation de clé. Le problème n'est donc pas la qualité de chaque base. C'est l'absence de pont entre elles.</a:t>
             </a:r>
           </a:p>
-          <a:p/>
+          <a:p>
+            <a:endParaRPr/>
+          </a:p>
           <a:p>
             <a:r>
               <a:t>→ Ce pont manquant se décompose en cinq manques.</a:t>
@@ -2740,7 +3041,7 @@
           <a:p>
             <a:fld id="{5BCAD085-E8A6-8845-BD4E-CB4CCA059FC4}" type="datetimeFigureOut">
               <a:rPr lang="en-US" smtClean="0"/>
-              <a:t>9/28/2026</a:t>
+              <a:t>9/30/2026</a:t>
             </a:fld>
             <a:endParaRPr lang="en-US"/>
           </a:p>
@@ -2908,7 +3209,7 @@
           <a:p>
             <a:fld id="{5BCAD085-E8A6-8845-BD4E-CB4CCA059FC4}" type="datetimeFigureOut">
               <a:rPr lang="en-US" smtClean="0"/>
-              <a:t>9/28/2026</a:t>
+              <a:t>9/30/2026</a:t>
             </a:fld>
             <a:endParaRPr lang="en-US"/>
           </a:p>
@@ -3086,7 +3387,7 @@
           <a:p>
             <a:fld id="{5BCAD085-E8A6-8845-BD4E-CB4CCA059FC4}" type="datetimeFigureOut">
               <a:rPr lang="en-US" smtClean="0"/>
-              <a:t>9/28/2026</a:t>
+              <a:t>9/30/2026</a:t>
             </a:fld>
             <a:endParaRPr lang="en-US"/>
           </a:p>
@@ -3254,7 +3555,7 @@
           <a:p>
             <a:fld id="{5BCAD085-E8A6-8845-BD4E-CB4CCA059FC4}" type="datetimeFigureOut">
               <a:rPr lang="en-US" smtClean="0"/>
-              <a:t>9/28/2026</a:t>
+              <a:t>9/30/2026</a:t>
             </a:fld>
             <a:endParaRPr lang="en-US"/>
           </a:p>
@@ -3499,7 +3800,7 @@
           <a:p>
             <a:fld id="{5BCAD085-E8A6-8845-BD4E-CB4CCA059FC4}" type="datetimeFigureOut">
               <a:rPr lang="en-US" smtClean="0"/>
-              <a:t>9/28/2026</a:t>
+              <a:t>9/30/2026</a:t>
             </a:fld>
             <a:endParaRPr lang="en-US"/>
           </a:p>
@@ -3784,7 +4085,7 @@
           <a:p>
             <a:fld id="{5BCAD085-E8A6-8845-BD4E-CB4CCA059FC4}" type="datetimeFigureOut">
               <a:rPr lang="en-US" smtClean="0"/>
-              <a:t>9/28/2026</a:t>
+              <a:t>9/30/2026</a:t>
             </a:fld>
             <a:endParaRPr lang="en-US"/>
           </a:p>
@@ -4203,7 +4504,7 @@
           <a:p>
             <a:fld id="{5BCAD085-E8A6-8845-BD4E-CB4CCA059FC4}" type="datetimeFigureOut">
               <a:rPr lang="en-US" smtClean="0"/>
-              <a:t>9/28/2026</a:t>
+              <a:t>9/30/2026</a:t>
             </a:fld>
             <a:endParaRPr lang="en-US"/>
           </a:p>
@@ -4320,7 +4621,7 @@
           <a:p>
             <a:fld id="{5BCAD085-E8A6-8845-BD4E-CB4CCA059FC4}" type="datetimeFigureOut">
               <a:rPr lang="en-US" smtClean="0"/>
-              <a:t>9/28/2026</a:t>
+              <a:t>9/30/2026</a:t>
             </a:fld>
             <a:endParaRPr lang="en-US"/>
           </a:p>
@@ -4415,7 +4716,7 @@
           <a:p>
             <a:fld id="{5BCAD085-E8A6-8845-BD4E-CB4CCA059FC4}" type="datetimeFigureOut">
               <a:rPr lang="en-US" smtClean="0"/>
-              <a:t>9/28/2026</a:t>
+              <a:t>9/30/2026</a:t>
             </a:fld>
             <a:endParaRPr lang="en-US"/>
           </a:p>
@@ -4690,7 +4991,7 @@
           <a:p>
             <a:fld id="{5BCAD085-E8A6-8845-BD4E-CB4CCA059FC4}" type="datetimeFigureOut">
               <a:rPr lang="en-US" smtClean="0"/>
-              <a:t>9/28/2026</a:t>
+              <a:t>9/30/2026</a:t>
             </a:fld>
             <a:endParaRPr lang="en-US"/>
           </a:p>
@@ -4942,7 +5243,7 @@
           <a:p>
             <a:fld id="{5BCAD085-E8A6-8845-BD4E-CB4CCA059FC4}" type="datetimeFigureOut">
               <a:rPr lang="en-US" smtClean="0"/>
-              <a:t>9/28/2026</a:t>
+              <a:t>9/30/2026</a:t>
             </a:fld>
             <a:endParaRPr lang="en-US"/>
           </a:p>
@@ -5153,7 +5454,7 @@
           <a:p>
             <a:fld id="{5BCAD085-E8A6-8845-BD4E-CB4CCA059FC4}" type="datetimeFigureOut">
               <a:rPr lang="en-US" smtClean="0"/>
-              <a:t>9/28/2026</a:t>
+              <a:t>9/30/2026</a:t>
             </a:fld>
             <a:endParaRPr lang="en-US"/>
           </a:p>
@@ -10590,62 +10891,17 @@
               </a:rPr>
               <a:t>Chaque décision porte méthode · explication</a:t>
             </a:r>
-            <a:r>
-              <a:rPr sz="1600" b="1" i="0">
+          </a:p>
+          <a:p>
+            <a:pPr algn="ctr"/>
+            <a:r>
+              <a:rPr sz="1500" b="0" i="0">
                 <a:solidFill>
                   <a:srgbClr val="FFFFFF"/>
                 </a:solidFill>
-                <a:latin typeface="Calibri"/>
-              </a:rPr>
-              <a:t/>
-            </a:r>
-          </a:p>
-          <a:p>
-            <a:pPr algn="ctr"/>
-            <a:r>
-              <a:rPr sz="1500" b="0" i="0">
-                <a:solidFill>
-                  <a:srgbClr val="FFFFFF"/>
-                </a:solidFill>
                 <a:latin typeface="Consolas"/>
               </a:rPr>
               <a:t>new_master · exact — identifiant dérivé de la clé</a:t>
-            </a:r>
-            <a:r>
-              <a:rPr sz="1600" b="0" i="0">
-                <a:solidFill>
-                  <a:srgbClr val="FFFFFF"/>
-                </a:solidFill>
-                <a:latin typeface="Calibri"/>
-              </a:rPr>
-              <a:t/>
-            </a:r>
-            <a:r>
-              <a:rPr sz="1500" b="0" i="0">
-                <a:solidFill>
-                  <a:srgbClr val="FFFFFF"/>
-                </a:solidFill>
-                <a:latin typeface="Consolas"/>
-              </a:rPr>
-              <a:t/>
-            </a:r>
-            <a:r>
-              <a:rPr sz="1600" b="0" i="0">
-                <a:solidFill>
-                  <a:srgbClr val="FFFFFF"/>
-                </a:solidFill>
-                <a:latin typeface="Calibri"/>
-              </a:rPr>
-              <a:t/>
-            </a:r>
-            <a:r>
-              <a:rPr sz="1500" b="0" i="0">
-                <a:solidFill>
-                  <a:srgbClr val="FFFFFF"/>
-                </a:solidFill>
-                <a:latin typeface="Consolas"/>
-              </a:rPr>
-              <a:t/>
             </a:r>
           </a:p>
         </p:txBody>
@@ -11206,51 +11462,6 @@
               </a:rPr>
               <a:t>Georges Grenier ×2 : même nom, même date, CIN différents</a:t>
             </a:r>
-            <a:r>
-              <a:rPr sz="1500" b="0" i="0">
-                <a:solidFill>
-                  <a:srgbClr val="1D2433"/>
-                </a:solidFill>
-                <a:latin typeface="Calibri"/>
-              </a:rPr>
-              <a:t/>
-            </a:r>
-            <a:r>
-              <a:rPr sz="1500" b="1" i="0">
-                <a:solidFill>
-                  <a:srgbClr val="1D2433"/>
-                </a:solidFill>
-                <a:latin typeface="Calibri"/>
-              </a:rPr>
-              <a:t/>
-            </a:r>
-            <a:r>
-              <a:rPr sz="1500" b="0" i="0">
-                <a:solidFill>
-                  <a:srgbClr val="1D2433"/>
-                </a:solidFill>
-                <a:latin typeface="Calibri"/>
-              </a:rPr>
-              <a:t/>
-            </a:r>
-            <a:r>
-              <a:rPr sz="1500" b="0" i="1">
-                <a:solidFill>
-                  <a:srgbClr val="1D2433"/>
-                </a:solidFill>
-                <a:latin typeface="Calibri"/>
-              </a:rPr>
-              <a:t/>
-            </a:r>
-            <a:r>
-              <a:rPr sz="1500" b="0" i="0">
-                <a:solidFill>
-                  <a:srgbClr val="1D2433"/>
-                </a:solidFill>
-                <a:latin typeface="Calibri"/>
-              </a:rPr>
-              <a:t/>
-            </a:r>
           </a:p>
           <a:p>
             <a:pPr algn="l">
@@ -11266,33 +11477,6 @@
                 <a:latin typeface="Calibri"/>
               </a:rPr>
               <a:t>v1 (score 0,80) : fusion à tort — v2 : deux patients distincts</a:t>
-            </a:r>
-            <a:r>
-              <a:rPr sz="1500" b="0" i="0">
-                <a:solidFill>
-                  <a:srgbClr val="1D2433"/>
-                </a:solidFill>
-                <a:latin typeface="Calibri"/>
-              </a:rPr>
-              <a:t/>
-            </a:r>
-            <a:r>
-              <a:rPr sz="1500" b="0" i="1">
-                <a:solidFill>
-                  <a:srgbClr val="1D2433"/>
-                </a:solidFill>
-                <a:latin typeface="Calibri"/>
-              </a:rPr>
-              <a:t/>
-            </a:r>
-            <a:r>
-              <a:rPr sz="1500" b="0" i="0">
-                <a:solidFill>
-                  <a:srgbClr val="1D2433"/>
-                </a:solidFill>
-                <a:latin typeface="Calibri"/>
-              </a:rPr>
-              <a:t/>
             </a:r>
           </a:p>
         </p:txBody>
@@ -15464,24 +15648,6 @@
               </a:rPr>
               <a:t>Rappel de 0,179 sur le jeu difficile (fiches incomplètes)</a:t>
             </a:r>
-            <a:r>
-              <a:rPr sz="1600" b="1" i="0">
-                <a:solidFill>
-                  <a:srgbClr val="1D2433"/>
-                </a:solidFill>
-                <a:latin typeface="Calibri"/>
-              </a:rPr>
-              <a:t/>
-            </a:r>
-            <a:r>
-              <a:rPr sz="1600" b="0" i="0">
-                <a:solidFill>
-                  <a:srgbClr val="1D2433"/>
-                </a:solidFill>
-                <a:latin typeface="Calibri"/>
-              </a:rPr>
-              <a:t/>
-            </a:r>
           </a:p>
           <a:p>
             <a:pPr marL="228600" indent="-201168" algn="l">
@@ -15502,24 +15668,6 @@
               </a:rPr>
               <a:t>Planification cron non activée : logique testée, pas encore observée</a:t>
             </a:r>
-            <a:r>
-              <a:rPr sz="1600" b="1" i="0">
-                <a:solidFill>
-                  <a:srgbClr val="1D2433"/>
-                </a:solidFill>
-                <a:latin typeface="Calibri"/>
-              </a:rPr>
-              <a:t/>
-            </a:r>
-            <a:r>
-              <a:rPr sz="1600" b="0" i="0">
-                <a:solidFill>
-                  <a:srgbClr val="1D2433"/>
-                </a:solidFill>
-                <a:latin typeface="Calibri"/>
-              </a:rPr>
-              <a:t/>
-            </a:r>
           </a:p>
           <a:p>
             <a:pPr marL="228600" indent="-201168" algn="l">
@@ -15540,24 +15688,6 @@
               </a:rPr>
               <a:t>Base centrale de test : consentements de démonstration</a:t>
             </a:r>
-            <a:r>
-              <a:rPr sz="1600" b="1" i="0">
-                <a:solidFill>
-                  <a:srgbClr val="1D2433"/>
-                </a:solidFill>
-                <a:latin typeface="Calibri"/>
-              </a:rPr>
-              <a:t/>
-            </a:r>
-            <a:r>
-              <a:rPr sz="1600" b="0" i="0">
-                <a:solidFill>
-                  <a:srgbClr val="1D2433"/>
-                </a:solidFill>
-                <a:latin typeface="Calibri"/>
-              </a:rPr>
-              <a:t/>
-            </a:r>
           </a:p>
           <a:p>
             <a:pPr marL="228600" indent="-201168" algn="l">
@@ -15578,24 +15708,6 @@
               </a:rPr>
               <a:t>Plateforme non déployée : prototype reproductible sur VM</a:t>
             </a:r>
-            <a:r>
-              <a:rPr sz="1600" b="1" i="0">
-                <a:solidFill>
-                  <a:srgbClr val="1D2433"/>
-                </a:solidFill>
-                <a:latin typeface="Calibri"/>
-              </a:rPr>
-              <a:t/>
-            </a:r>
-            <a:r>
-              <a:rPr sz="1600" b="0" i="0">
-                <a:solidFill>
-                  <a:srgbClr val="1D2433"/>
-                </a:solidFill>
-                <a:latin typeface="Calibri"/>
-              </a:rPr>
-              <a:t/>
-            </a:r>
           </a:p>
         </p:txBody>
       </p:sp>
@@ -15721,15 +15833,6 @@
               </a:rPr>
               <a:t>Court terme : consentement par type de dossier, validation des fiches incomplètes, activation du cron</a:t>
             </a:r>
-            <a:r>
-              <a:rPr sz="1600" b="0" i="0">
-                <a:solidFill>
-                  <a:srgbClr val="1D2433"/>
-                </a:solidFill>
-                <a:latin typeface="Calibri"/>
-              </a:rPr>
-              <a:t/>
-            </a:r>
           </a:p>
           <a:p>
             <a:pPr marL="228600" indent="-201168" algn="l">
@@ -15750,15 +15853,6 @@
               </a:rPr>
               <a:t>Moyen terme : intégration continue, lignes nouvelles seules, plusieurs nœuds</a:t>
             </a:r>
-            <a:r>
-              <a:rPr sz="1600" b="0" i="0">
-                <a:solidFill>
-                  <a:srgbClr val="1D2433"/>
-                </a:solidFill>
-                <a:latin typeface="Calibri"/>
-              </a:rPr>
-              <a:t/>
-            </a:r>
           </a:p>
           <a:p>
             <a:pPr marL="228600" indent="-201168" algn="l">
@@ -15778,15 +15872,6 @@
                 <a:latin typeface="Calibri"/>
               </a:rPr>
               <a:t>Long terme : catalogue de métadonnées, autres entités (médecins, médicaments)</a:t>
-            </a:r>
-            <a:r>
-              <a:rPr sz="1600" b="0" i="0">
-                <a:solidFill>
-                  <a:srgbClr val="1D2433"/>
-                </a:solidFill>
-                <a:latin typeface="Calibri"/>
-              </a:rPr>
-              <a:t/>
             </a:r>
           </a:p>
         </p:txBody>

</xml_diff>

<commit_message>
Mémoire et soutenance : versions V1 à envoyer, documents alignés sur le 30/09
Alignement du 30/09 (session précédente) :
- chapitres 5, 7, 8, 9 et annexes : 160 tests, API de gouvernance testée sur
  un vrai PostgreSQL, vue analytique GOLD réservée aux patients consentants,
  FHIR « partiel, testé » ;
- rapport, script oral et deck sur les mêmes chiffres ; capture C15 et
  figure 9 refaites.

Versions V1 :
- export_memoire_docx.py : option --chapitres (page de garde, plan complet
  avec renvois de page, chapitres retenus seuls) ; export complet inchangé ;
- export_presentation_docx.py : support de soutenance en Word, une page par
  slide (image, durée, texte oral) ; la démonstration y est racontée en
  scénario, appuyé sur les captures du 30/09 ;
- deck : coquille corrigée dans les notes de la slide 1.

Les DOCX produits restent hors dépôt (documents/*.docx).
Tests : 160 réussis, 2 ignorés (parités Spark, exécutées dans la VM).

Co-Authored-By: Claude Opus 5.5 <noreply@anthropic.com>
</commit_message>
<xml_diff>
--- a/documents/slide_soutenance/Soutenance_M2_MBDS_RANOMENJANAHARY.pptx
+++ b/documents/slide_soutenance/Soutenance_M2_MBDS_RANOMENJANAHARY.pptx
@@ -1031,7 +1031,7 @@
             </a:r>
             <a:r>
               <a:rPr lang="en-US" dirty="0"/>
-              <a:t> donner la </a:t>
+              <a:t> donné la </a:t>
             </a:r>
             <a:r>
               <a:rPr lang="en-US"/>
@@ -1493,7 +1493,7 @@
           <a:lstStyle/>
           <a:p>
             <a:r>
-              <a:t>Les sources sont copiées telles quelles dans la zone RAW, sur HDFS. Elles sont ensuite harmonisées au format FHIR dans la zone SILVER, où le moteur rattache chaque fiche à son patient maître. La zone GOLD porte les agrégats et le consentement. PostgreSQL garde l'état de référence : patients maîtres, consentements, journal d'audit. Et l'API de gouvernance est la seule porte d'entrée : chaque appel y est journalisé. Le tout tourne sur une machine virtuelle de 8 Go, avec des outils libres.</a:t>
+              <a:t>Les sources sont copiées telles quelles dans la zone RAW, sur HDFS. Elles sont ensuite harmonisées selon un schéma inspiré de FHIR dans la zone SILVER, où le moteur rattache chaque fiche à son patient maître. La zone GOLD porte les agrégats et le consentement. PostgreSQL garde l'état de référence : patients maîtres, consentements, journal d'audit. Et l'API de gouvernance est la seule porte d'entrée : chaque appel y est journalisé. Le tout tourne sur une machine virtuelle de 8 Go, avec des outils libres.</a:t>
             </a:r>
           </a:p>
           <a:p>
@@ -1751,7 +1751,7 @@
           <a:lstStyle/>
           <a:p>
             <a:r>
-              <a:t>Sur le jeu difficile, rejoué dans la VM : 1 057 fiches, 942 patients distincts, 115 doublons rattachés. La cohérence se vérifie par une soustraction : 1 057 moins 115, 942. Sur 100 000 patients, le run complet prend moins de trois minutes. Et les 131 tests passent.</a:t>
+              <a:t>Sur le jeu difficile, rejoué dans la VM : 1 057 fiches, 942 patients distincts, 115 doublons rattachés. La cohérence se vérifie par une soustraction : 1 057 moins 115, 942. Sur 100 000 patients, le run complet prend moins de trois minutes. Et les 160 tests passent.</a:t>
             </a:r>
           </a:p>
           <a:p>
@@ -1931,7 +1931,7 @@
           </a:p>
           <a:p>
             <a:r>
-              <a:t>131 tests, aucun échec : moteur, gouvernance, pipeline.</a:t>
+              <a:t>160 tests, aucun échec : moteur, gouvernance, pipeline.</a:t>
             </a:r>
           </a:p>
           <a:p>
@@ -2751,7 +2751,7 @@
           </a:p>
           <a:p>
             <a:r>
-              <a:t>Aucune ne coche les six critères. J'ai donc construit une chaîne sur mesure, mais adossée aux standards : Fellegi-Sunter pour la décision, FHIR pour le format, Medallion pour le lac.</a:t>
+              <a:t>Aucune ne coche les six critères. J'ai donc construit une chaîne sur mesure, mais adossée aux standards : Fellegi-Sunter pour la décision, FHIR comme modèle du format pivot, Medallion pour le lac.</a:t>
             </a:r>
           </a:p>
           <a:p>
@@ -9328,7 +9328,7 @@
                 </a:solidFill>
                 <a:latin typeface="Calibri"/>
               </a:rPr>
-              <a:t>FHIR normalisé</a:t>
+              <a:t>inspiré de FHIR</a:t>
             </a:r>
           </a:p>
           <a:p>
@@ -9610,7 +9610,7 @@
                 </a:solidFill>
                 <a:latin typeface="Calibri"/>
               </a:rPr>
-              <a:t>exact + probabiliste</a:t>
+              <a:t>règle d'identité stricte</a:t>
             </a:r>
           </a:p>
         </p:txBody>
@@ -13681,7 +13681,7 @@
                 </a:solidFill>
                 <a:latin typeface="Calibri"/>
               </a:rPr>
-              <a:t>131 / 131</a:t>
+              <a:t>160 / 160</a:t>
             </a:r>
           </a:p>
         </p:txBody>
@@ -14892,7 +14892,7 @@
                 </a:solidFill>
                 <a:latin typeface="Calibri"/>
               </a:rPr>
-              <a:t>Tests automatisés : 131 / 131</a:t>
+              <a:t>Tests automatisés : 160 / 160</a:t>
             </a:r>
           </a:p>
         </p:txBody>
@@ -16793,7 +16793,7 @@
                 </a:solidFill>
                 <a:latin typeface="Calibri"/>
               </a:rPr>
-              <a:t>exact + probabiliste, explicable</a:t>
+              <a:t>règle stricte, explicable</a:t>
             </a:r>
           </a:p>
         </p:txBody>
@@ -25499,11 +25499,11 @@
                       <a:r>
                         <a:rPr sz="2000" b="1" i="0">
                           <a:solidFill>
-                            <a:srgbClr val="2E7D4F"/>
+                            <a:srgbClr val="C78400"/>
                           </a:solidFill>
                           <a:latin typeface="Calibri"/>
                         </a:rPr>
-                        <a:t>✔</a:t>
+                        <a:t>◐</a:t>
                       </a:r>
                     </a:p>
                   </a:txBody>

</xml_diff>